<commit_message>
Add ch.18 supply-chain-security capstone + diagrams; deck r01.3 close-out section
</commit_message>
<xml_diff>
--- a/presentations/hummingbird-overview.pptx
+++ b/presentations/hummingbird-overview.pptx
@@ -38,9 +38,13 @@
     <p:sldId id="286" r:id="rId32"/>
     <p:sldId id="287" r:id="rId33"/>
     <p:sldId id="288" r:id="rId34"/>
+    <p:sldId id="289" r:id="rId35"/>
+    <p:sldId id="290" r:id="rId36"/>
+    <p:sldId id="291" r:id="rId37"/>
+    <p:sldId id="292" r:id="rId38"/>
   </p:sldIdLst>
   <p:notesMasterIdLst>
-    <p:notesMasterId r:id="rId35"/>
+    <p:notesMasterId r:id="rId39"/>
   </p:notesMasterIdLst>
   <p:sldSz cx="12192000" cy="6858000"/>
   <p:notesSz cx="6858000" cy="12192000"/>
@@ -2822,7 +2826,7 @@
           <a:p>
             <a:r>
               <a:rPr lang="en-US" dirty="0"/>
-              <a:t>Recap the arc and point to where to go deeper. One idea drives everything — rebuild instead of patch — and it gives you distroless, near-zero-CVE images on a trust chain you may already rely on. The entire workflow fits on a laptop with Podman. The strongest closing note for an admin audience: near-zero CVE isn't something to take on faith — it's one Grype command away from being your own measurement, and the work that remains is the tractable part, keeping your own dependencies current. And it's not all-or-nothing: use Hummingbird where minimalism wins and UBI where breadth does. Everything in this deck — chapters, runnable examples, and the demos — lives in the tutorial repo and site.</a:t>
+              <a:t>This close-out borrows the canonical container supply-chain threat model from Liz Rice's Container Security (2nd edition, chapter 7) and reframes it for Podman, OpenShift, and RHEL. The goal for the audience: Hummingbird is, in large part, an answer to this model — it closes the hardest vectors by construction — while source/Containerfile integrity, host and platform hardening, and the admission gate stay the operator's job.</a:t>
             </a:r>
             <a:endParaRPr lang="en-US" dirty="0"/>
           </a:p>
@@ -2846,6 +2850,358 @@
             <a:fld id="{F7021451-1387-4CA6-816F-3879F97B5CBC}" type="slidenum">
               <a:rPr lang="en-US"/>
               <a:t>33</a:t>
+            </a:fld>
+            <a:endParaRPr lang="en-US"/>
+          </a:p>
+        </p:txBody>
+      </p:sp>
+    </p:spTree>
+    <p:extLst>
+      <p:ext uri="{BB962C8B-B14F-4D97-AF65-F5344CB8AC3E}">
+        <p14:creationId xmlns:p14="http://schemas.microsoft.com/office/powerpoint/2010/main" val="1024086991"/>
+      </p:ext>
+    </p:extLst>
+  </p:cSld>
+  <p:clrMapOvr>
+    <a:masterClrMapping/>
+  </p:clrMapOvr>
+</p:notes>
+</file>
+
+<file path=ppt/notesSlides/notesSlide34.xml><?xml version="1.0" encoding="utf-8"?>
+<p:notes xmlns:a="http://schemas.openxmlformats.org/drawingml/2006/main" xmlns:r="http://schemas.openxmlformats.org/officeDocument/2006/relationships" xmlns:p="http://schemas.openxmlformats.org/presentationml/2006/main">
+  <p:cSld>
+    <p:spTree>
+      <p:nvGrpSpPr>
+        <p:cNvPr id="1" name=""/>
+        <p:cNvGrpSpPr/>
+        <p:nvPr/>
+      </p:nvGrpSpPr>
+      <p:grpSpPr>
+        <a:xfrm>
+          <a:off x="0" y="0"/>
+          <a:ext cx="0" cy="0"/>
+          <a:chOff x="0" y="0"/>
+          <a:chExt cx="0" cy="0"/>
+        </a:xfrm>
+      </p:grpSpPr>
+      <p:sp>
+        <p:nvSpPr>
+          <p:cNvPr id="2" name="Slide Image Placeholder 1"/>
+          <p:cNvSpPr>
+            <a:spLocks noGrp="1" noRot="1" noChangeAspect="1"/>
+          </p:cNvSpPr>
+          <p:nvPr>
+            <p:ph type="sldImg"/>
+          </p:nvPr>
+        </p:nvSpPr>
+        <p:spPr/>
+      </p:sp>
+      <p:sp>
+        <p:nvSpPr>
+          <p:cNvPr id="3" name="Notes Placeholder 2"/>
+          <p:cNvSpPr>
+            <a:spLocks noGrp="1"/>
+          </p:cNvSpPr>
+          <p:nvPr>
+            <p:ph type="body" idx="1"/>
+          </p:nvPr>
+        </p:nvSpPr>
+        <p:spPr/>
+        <p:txBody>
+          <a:bodyPr/>
+          <a:lstStyle/>
+          <a:p>
+            <a:r>
+              <a:rPr lang="en-US" dirty="0"/>
+              <a:t>The canonical container supply-chain threat model, reframed for our stack: Buildah/Konflux instead of Docker, the signed registry.access.redhat.com/hi path, OpenShift at deploy. Top row: the classic vectors. Bottom row: the Hummingbird answer. The story to tell — a hardened base turns the three hardest vectors (vulnerable base, vulnerable dependencies, build tampering) from 'trust us' into signed evidence you verify yourself, and the minimalism means there's simply less inside to be vulnerable. Be candid about the left edge: tampered source and a tampered Containerfile are the operator's job — branch protection, signed commits, pin the base by digest. Hummingbird gives you a trustworthy FROM; it can't stop an insecure Containerfile on top of it.</a:t>
+            </a:r>
+            <a:endParaRPr lang="en-US" dirty="0"/>
+          </a:p>
+        </p:txBody>
+      </p:sp>
+      <p:sp>
+        <p:nvSpPr>
+          <p:cNvPr id="4" name="Slide Number Placeholder 3"/>
+          <p:cNvSpPr>
+            <a:spLocks noGrp="1"/>
+          </p:cNvSpPr>
+          <p:nvPr>
+            <p:ph type="sldNum" sz="quarter" idx="10"/>
+          </p:nvPr>
+        </p:nvSpPr>
+        <p:spPr/>
+        <p:txBody>
+          <a:bodyPr/>
+          <a:lstStyle/>
+          <a:p>
+            <a:fld id="{F7021451-1387-4CA6-816F-3879F97B5CBC}" type="slidenum">
+              <a:rPr lang="en-US"/>
+              <a:t>34</a:t>
+            </a:fld>
+            <a:endParaRPr lang="en-US"/>
+          </a:p>
+        </p:txBody>
+      </p:sp>
+    </p:spTree>
+    <p:extLst>
+      <p:ext uri="{BB962C8B-B14F-4D97-AF65-F5344CB8AC3E}">
+        <p14:creationId xmlns:p14="http://schemas.microsoft.com/office/powerpoint/2010/main" val="1024086991"/>
+      </p:ext>
+    </p:extLst>
+  </p:cSld>
+  <p:clrMapOvr>
+    <a:masterClrMapping/>
+  </p:clrMapOvr>
+</p:notes>
+</file>
+
+<file path=ppt/notesSlides/notesSlide35.xml><?xml version="1.0" encoding="utf-8"?>
+<p:notes xmlns:a="http://schemas.openxmlformats.org/drawingml/2006/main" xmlns:r="http://schemas.openxmlformats.org/officeDocument/2006/relationships" xmlns:p="http://schemas.openxmlformats.org/presentationml/2006/main">
+  <p:cSld>
+    <p:spTree>
+      <p:nvGrpSpPr>
+        <p:cNvPr id="1" name=""/>
+        <p:cNvGrpSpPr/>
+        <p:nvPr/>
+      </p:nvGrpSpPr>
+      <p:grpSpPr>
+        <a:xfrm>
+          <a:off x="0" y="0"/>
+          <a:ext cx="0" cy="0"/>
+          <a:chOff x="0" y="0"/>
+          <a:chExt cx="0" cy="0"/>
+        </a:xfrm>
+      </p:grpSpPr>
+      <p:sp>
+        <p:nvSpPr>
+          <p:cNvPr id="2" name="Slide Image Placeholder 1"/>
+          <p:cNvSpPr>
+            <a:spLocks noGrp="1" noRot="1" noChangeAspect="1"/>
+          </p:cNvSpPr>
+          <p:nvPr>
+            <p:ph type="sldImg"/>
+          </p:nvPr>
+        </p:nvSpPr>
+        <p:spPr/>
+      </p:sp>
+      <p:sp>
+        <p:nvSpPr>
+          <p:cNvPr id="3" name="Notes Placeholder 2"/>
+          <p:cNvSpPr>
+            <a:spLocks noGrp="1"/>
+          </p:cNvSpPr>
+          <p:nvPr>
+            <p:ph type="body" idx="1"/>
+          </p:nvPr>
+        </p:nvSpPr>
+        <p:spPr/>
+        <p:txBody>
+          <a:bodyPr/>
+          <a:lstStyle/>
+          <a:p>
+            <a:r>
+              <a:rPr lang="en-US" dirty="0"/>
+              <a:t>The pipeline view was build-and-delivery; this is runtime — defense in depth. The hardened image shrinks the cluster of vectors aimed at the image and the app: a swapped image fails cosign verify; distroless removes the foot-guns (no shell, no package manager, non-root UID 65532); fewer packages mean fewer exploitable paths and very little for an intruder to use if they do land inside. What it does NOT fix sits outside the container — misconfigured host, insecure networking, container escape — and those are platform hardening: rootless Podman, SELinux, seccomp, OpenShift SCCs, network policy. The hardened image is one strong layer, not the whole onion.</a:t>
+            </a:r>
+            <a:endParaRPr lang="en-US" dirty="0"/>
+          </a:p>
+        </p:txBody>
+      </p:sp>
+      <p:sp>
+        <p:nvSpPr>
+          <p:cNvPr id="4" name="Slide Number Placeholder 3"/>
+          <p:cNvSpPr>
+            <a:spLocks noGrp="1"/>
+          </p:cNvSpPr>
+          <p:nvPr>
+            <p:ph type="sldNum" sz="quarter" idx="10"/>
+          </p:nvPr>
+        </p:nvSpPr>
+        <p:spPr/>
+        <p:txBody>
+          <a:bodyPr/>
+          <a:lstStyle/>
+          <a:p>
+            <a:fld id="{F7021451-1387-4CA6-816F-3879F97B5CBC}" type="slidenum">
+              <a:rPr lang="en-US"/>
+              <a:t>35</a:t>
+            </a:fld>
+            <a:endParaRPr lang="en-US"/>
+          </a:p>
+        </p:txBody>
+      </p:sp>
+    </p:spTree>
+    <p:extLst>
+      <p:ext uri="{BB962C8B-B14F-4D97-AF65-F5344CB8AC3E}">
+        <p14:creationId xmlns:p14="http://schemas.microsoft.com/office/powerpoint/2010/main" val="1024086991"/>
+      </p:ext>
+    </p:extLst>
+  </p:cSld>
+  <p:clrMapOvr>
+    <a:masterClrMapping/>
+  </p:clrMapOvr>
+</p:notes>
+</file>
+
+<file path=ppt/notesSlides/notesSlide36.xml><?xml version="1.0" encoding="utf-8"?>
+<p:notes xmlns:a="http://schemas.openxmlformats.org/drawingml/2006/main" xmlns:r="http://schemas.openxmlformats.org/officeDocument/2006/relationships" xmlns:p="http://schemas.openxmlformats.org/presentationml/2006/main">
+  <p:cSld>
+    <p:spTree>
+      <p:nvGrpSpPr>
+        <p:cNvPr id="1" name=""/>
+        <p:cNvGrpSpPr/>
+        <p:nvPr/>
+      </p:nvGrpSpPr>
+      <p:grpSpPr>
+        <a:xfrm>
+          <a:off x="0" y="0"/>
+          <a:ext cx="0" cy="0"/>
+          <a:chOff x="0" y="0"/>
+          <a:chExt cx="0" cy="0"/>
+        </a:xfrm>
+      </p:grpSpPr>
+      <p:sp>
+        <p:nvSpPr>
+          <p:cNvPr id="2" name="Slide Image Placeholder 1"/>
+          <p:cNvSpPr>
+            <a:spLocks noGrp="1" noRot="1" noChangeAspect="1"/>
+          </p:cNvSpPr>
+          <p:nvPr>
+            <p:ph type="sldImg"/>
+          </p:nvPr>
+        </p:nvSpPr>
+        <p:spPr/>
+      </p:sp>
+      <p:sp>
+        <p:nvSpPr>
+          <p:cNvPr id="3" name="Notes Placeholder 2"/>
+          <p:cNvSpPr>
+            <a:spLocks noGrp="1"/>
+          </p:cNvSpPr>
+          <p:nvPr>
+            <p:ph type="body" idx="1"/>
+          </p:nvPr>
+        </p:nvSpPr>
+        <p:spPr/>
+        <p:txBody>
+          <a:bodyPr/>
+          <a:lstStyle/>
+          <a:p>
+            <a:r>
+              <a:rPr lang="en-US" dirty="0"/>
+              <a:t>The honest summary, and a good place to end an admin talk. Hummingbird owns the image — vulnerable base, vulnerable dependencies, build integrity, image authenticity — the part that's genuinely hard to do yourself and that you get for free. You own the edges — source and Containerfile integrity, platform hardening, and the admission gate that enforces verification for every deploy. The practical close: verify on pull with podman + cosign, and enforce it cluster-wide with an OpenShift admission policy so no one can route around the check — that's what closes the malicious-deployment-definition vector. A near-zero-CVE distroless base is the strongest single move on the supply chain precisely because it collapses the vectors that are hardest to defend one at a time.</a:t>
+            </a:r>
+            <a:endParaRPr lang="en-US" dirty="0"/>
+          </a:p>
+        </p:txBody>
+      </p:sp>
+      <p:sp>
+        <p:nvSpPr>
+          <p:cNvPr id="4" name="Slide Number Placeholder 3"/>
+          <p:cNvSpPr>
+            <a:spLocks noGrp="1"/>
+          </p:cNvSpPr>
+          <p:nvPr>
+            <p:ph type="sldNum" sz="quarter" idx="10"/>
+          </p:nvPr>
+        </p:nvSpPr>
+        <p:spPr/>
+        <p:txBody>
+          <a:bodyPr/>
+          <a:lstStyle/>
+          <a:p>
+            <a:fld id="{F7021451-1387-4CA6-816F-3879F97B5CBC}" type="slidenum">
+              <a:rPr lang="en-US"/>
+              <a:t>36</a:t>
+            </a:fld>
+            <a:endParaRPr lang="en-US"/>
+          </a:p>
+        </p:txBody>
+      </p:sp>
+    </p:spTree>
+    <p:extLst>
+      <p:ext uri="{BB962C8B-B14F-4D97-AF65-F5344CB8AC3E}">
+        <p14:creationId xmlns:p14="http://schemas.microsoft.com/office/powerpoint/2010/main" val="1024086991"/>
+      </p:ext>
+    </p:extLst>
+  </p:cSld>
+  <p:clrMapOvr>
+    <a:masterClrMapping/>
+  </p:clrMapOvr>
+</p:notes>
+</file>
+
+<file path=ppt/notesSlides/notesSlide37.xml><?xml version="1.0" encoding="utf-8"?>
+<p:notes xmlns:a="http://schemas.openxmlformats.org/drawingml/2006/main" xmlns:r="http://schemas.openxmlformats.org/officeDocument/2006/relationships" xmlns:p="http://schemas.openxmlformats.org/presentationml/2006/main">
+  <p:cSld>
+    <p:spTree>
+      <p:nvGrpSpPr>
+        <p:cNvPr id="1" name=""/>
+        <p:cNvGrpSpPr/>
+        <p:nvPr/>
+      </p:nvGrpSpPr>
+      <p:grpSpPr>
+        <a:xfrm>
+          <a:off x="0" y="0"/>
+          <a:ext cx="0" cy="0"/>
+          <a:chOff x="0" y="0"/>
+          <a:chExt cx="0" cy="0"/>
+        </a:xfrm>
+      </p:grpSpPr>
+      <p:sp>
+        <p:nvSpPr>
+          <p:cNvPr id="2" name="Slide Image Placeholder 1"/>
+          <p:cNvSpPr>
+            <a:spLocks noGrp="1" noRot="1" noChangeAspect="1"/>
+          </p:cNvSpPr>
+          <p:nvPr>
+            <p:ph type="sldImg"/>
+          </p:nvPr>
+        </p:nvSpPr>
+        <p:spPr/>
+      </p:sp>
+      <p:sp>
+        <p:nvSpPr>
+          <p:cNvPr id="3" name="Notes Placeholder 2"/>
+          <p:cNvSpPr>
+            <a:spLocks noGrp="1"/>
+          </p:cNvSpPr>
+          <p:nvPr>
+            <p:ph type="body" idx="1"/>
+          </p:nvPr>
+        </p:nvSpPr>
+        <p:spPr/>
+        <p:txBody>
+          <a:bodyPr/>
+          <a:lstStyle/>
+          <a:p>
+            <a:r>
+              <a:rPr lang="en-US" dirty="0"/>
+              <a:t>Recap the arc and point to where to go deeper. One idea drives everything — rebuild instead of patch — and it gives you distroless, near-zero-CVE images on a trust chain you may already rely on. The entire workflow fits on a laptop with Podman. The strongest closing note for an admin audience: near-zero CVE isn't something to take on faith — it's one Grype command away from being your own measurement, and the work that remains is the tractable part, keeping your own dependencies current. And it's not all-or-nothing: use Hummingbird where minimalism wins and UBI where breadth does. Everything in this deck — chapters, runnable examples, and the demos — lives in the tutorial repo and site.</a:t>
+            </a:r>
+            <a:endParaRPr lang="en-US" dirty="0"/>
+          </a:p>
+        </p:txBody>
+      </p:sp>
+      <p:sp>
+        <p:nvSpPr>
+          <p:cNvPr id="4" name="Slide Number Placeholder 3"/>
+          <p:cNvSpPr>
+            <a:spLocks noGrp="1"/>
+          </p:cNvSpPr>
+          <p:nvPr>
+            <p:ph type="sldNum" sz="quarter" idx="10"/>
+          </p:nvPr>
+        </p:nvSpPr>
+        <p:spPr/>
+        <p:txBody>
+          <a:bodyPr/>
+          <a:lstStyle/>
+          <a:p>
+            <a:fld id="{F7021451-1387-4CA6-816F-3879F97B5CBC}" type="slidenum">
+              <a:rPr lang="en-US"/>
+              <a:t>37</a:t>
             </a:fld>
             <a:endParaRPr lang="en-US"/>
           </a:p>
@@ -3914,7 +4270,7 @@
                 <a:ea typeface="Red Hat Mono" pitchFamily="34" charset="-122"/>
                 <a:cs typeface="Red Hat Mono" pitchFamily="34" charset="-120"/>
               </a:rPr>
-              <a:t>r01.2</a:t>
+              <a:t>r01.3</a:t>
             </a:r>
             <a:endParaRPr lang="en-US" sz="1100" dirty="0"/>
           </a:p>
@@ -13192,6 +13548,13 @@
 <file path=ppt/slides/slide33.xml><?xml version="1.0" encoding="utf-8"?>
 <p:sld xmlns:a="http://schemas.openxmlformats.org/drawingml/2006/main" xmlns:r="http://schemas.openxmlformats.org/officeDocument/2006/relationships" xmlns:p="http://schemas.openxmlformats.org/presentationml/2006/main">
   <p:cSld name="Slide 33">
+    <p:bg>
+      <p:bgPr>
+        <a:solidFill>
+          <a:srgbClr val="AB0000"/>
+        </a:solidFill>
+      </p:bgPr>
+    </p:bg>
     <p:spTree>
       <p:nvGrpSpPr>
         <p:cNvPr id="1" name=""/>
@@ -13206,16 +13569,40 @@
           <a:chExt cx="0" cy="0"/>
         </a:xfrm>
       </p:grpSpPr>
-      <p:sp>
-        <p:nvSpPr>
-          <p:cNvPr id="2" name="Text 0"/>
+      <p:pic>
+        <p:nvPicPr>
+          <p:cNvPr id="2" name="Image 0" descr="./assets/section-panel.png">    </p:cNvPr>
+          <p:cNvPicPr>
+            <a:picLocks noChangeAspect="1"/>
+          </p:cNvPicPr>
+          <p:nvPr/>
+        </p:nvPicPr>
+        <p:blipFill>
+          <a:blip r:embed="rId1"/>
+          <a:stretch>
+            <a:fillRect/>
+          </a:stretch>
+        </p:blipFill>
+        <p:spPr>
+          <a:xfrm>
+            <a:off x="0" y="0"/>
+            <a:ext cx="12191695" cy="6858000"/>
+          </a:xfrm>
+          <a:prstGeom prst="rect">
+            <a:avLst/>
+          </a:prstGeom>
+        </p:spPr>
+      </p:pic>
+      <p:sp>
+        <p:nvSpPr>
+          <p:cNvPr id="3" name="Text 0"/>
           <p:cNvSpPr/>
           <p:nvPr/>
         </p:nvSpPr>
         <p:spPr>
           <a:xfrm>
-            <a:off x="566928" y="6364224"/>
-            <a:ext cx="914400" cy="274320"/>
+            <a:off x="5733288" y="2121408"/>
+            <a:ext cx="5852160" cy="457200"/>
           </a:xfrm>
           <a:prstGeom prst="rect">
             <a:avLst/>
@@ -13231,15 +13618,2055 @@
               <a:buNone/>
             </a:pPr>
             <a:r>
-              <a:rPr lang="en-US" sz="1000" dirty="0">
-                <a:solidFill>
-                  <a:srgbClr val="8A8A8A"/>
+              <a:rPr lang="en-US" sz="2200" b="1" spc="600" kern="0" dirty="0">
+                <a:solidFill>
+                  <a:srgbClr val="FFFFFF"/>
+                </a:solidFill>
+                <a:latin typeface="Overpass" pitchFamily="34" charset="0"/>
+                <a:ea typeface="Overpass" pitchFamily="34" charset="-122"/>
+                <a:cs typeface="Overpass" pitchFamily="34" charset="-120"/>
+              </a:rPr>
+              <a:t>04</a:t>
+            </a:r>
+            <a:endParaRPr lang="en-US" sz="2200" dirty="0"/>
+          </a:p>
+        </p:txBody>
+      </p:sp>
+      <p:sp>
+        <p:nvSpPr>
+          <p:cNvPr id="4" name="Text 1"/>
+          <p:cNvSpPr/>
+          <p:nvPr/>
+        </p:nvSpPr>
+        <p:spPr>
+          <a:xfrm>
+            <a:off x="5705856" y="2596896"/>
+            <a:ext cx="6126480" cy="1463040"/>
+          </a:xfrm>
+          <a:prstGeom prst="rect">
+            <a:avLst/>
+          </a:prstGeom>
+          <a:noFill/>
+          <a:ln/>
+        </p:spPr>
+        <p:txBody>
+          <a:bodyPr wrap="square" rtlCol="0" anchor="t"/>
+          <a:lstStyle/>
+          <a:p>
+            <a:pPr algn="l" indent="0" marL="0">
+              <a:buNone/>
+            </a:pPr>
+            <a:r>
+              <a:rPr lang="en-US" sz="4400" b="1" dirty="0">
+                <a:solidFill>
+                  <a:srgbClr val="FFFFFF"/>
+                </a:solidFill>
+                <a:latin typeface="Overpass" pitchFamily="34" charset="0"/>
+                <a:ea typeface="Overpass" pitchFamily="34" charset="-122"/>
+                <a:cs typeface="Overpass" pitchFamily="34" charset="-120"/>
+              </a:rPr>
+              <a:t>Supply chain security</a:t>
+            </a:r>
+            <a:endParaRPr lang="en-US" sz="4400" dirty="0"/>
+          </a:p>
+        </p:txBody>
+      </p:sp>
+      <p:sp>
+        <p:nvSpPr>
+          <p:cNvPr id="5" name="Text 2"/>
+          <p:cNvSpPr/>
+          <p:nvPr/>
+        </p:nvSpPr>
+        <p:spPr>
+          <a:xfrm>
+            <a:off x="5733288" y="4160520"/>
+            <a:ext cx="6035040" cy="731520"/>
+          </a:xfrm>
+          <a:prstGeom prst="rect">
+            <a:avLst/>
+          </a:prstGeom>
+          <a:noFill/>
+          <a:ln/>
+        </p:spPr>
+        <p:txBody>
+          <a:bodyPr wrap="square" rtlCol="0" anchor="t"/>
+          <a:lstStyle/>
+          <a:p>
+            <a:pPr algn="l" indent="0" marL="0">
+              <a:buNone/>
+            </a:pPr>
+            <a:r>
+              <a:rPr lang="en-US" sz="1600" i="1" dirty="0">
+                <a:solidFill>
+                  <a:srgbClr val="FFD9D9"/>
                 </a:solidFill>
                 <a:latin typeface="Red Hat Text" pitchFamily="34" charset="0"/>
                 <a:ea typeface="Red Hat Text" pitchFamily="34" charset="-122"/>
                 <a:cs typeface="Red Hat Text" pitchFamily="34" charset="-120"/>
               </a:rPr>
-              <a:t>33</a:t>
+              <a:t>Where a hardened base fits the bigger threat model.</a:t>
+            </a:r>
+            <a:endParaRPr lang="en-US" sz="1600" dirty="0"/>
+          </a:p>
+        </p:txBody>
+      </p:sp>
+      <p:pic>
+        <p:nvPicPr>
+          <p:cNvPr id="6" name="Image 1" descr="./assets/redhat-logo-white.png">    </p:cNvPr>
+          <p:cNvPicPr>
+            <a:picLocks noChangeAspect="1"/>
+          </p:cNvPicPr>
+          <p:nvPr/>
+        </p:nvPicPr>
+        <p:blipFill>
+          <a:blip r:embed="rId2"/>
+          <a:stretch>
+            <a:fillRect/>
+          </a:stretch>
+        </p:blipFill>
+        <p:spPr>
+          <a:xfrm>
+            <a:off x="10442448" y="6291072"/>
+            <a:ext cx="1216152" cy="283464"/>
+          </a:xfrm>
+          <a:prstGeom prst="rect">
+            <a:avLst/>
+          </a:prstGeom>
+        </p:spPr>
+      </p:pic>
+    </p:spTree>
+  </p:cSld>
+  <p:clrMapOvr>
+    <a:masterClrMapping/>
+  </p:clrMapOvr>
+</p:sld>
+</file>
+
+<file path=ppt/slides/slide34.xml><?xml version="1.0" encoding="utf-8"?>
+<p:sld xmlns:a="http://schemas.openxmlformats.org/drawingml/2006/main" xmlns:r="http://schemas.openxmlformats.org/officeDocument/2006/relationships" xmlns:p="http://schemas.openxmlformats.org/presentationml/2006/main">
+  <p:cSld name="Slide 34">
+    <p:spTree>
+      <p:nvGrpSpPr>
+        <p:cNvPr id="1" name=""/>
+        <p:cNvGrpSpPr/>
+        <p:nvPr/>
+      </p:nvGrpSpPr>
+      <p:grpSpPr>
+        <a:xfrm>
+          <a:off x="0" y="0"/>
+          <a:ext cx="0" cy="0"/>
+          <a:chOff x="0" y="0"/>
+          <a:chExt cx="0" cy="0"/>
+        </a:xfrm>
+      </p:grpSpPr>
+      <p:sp>
+        <p:nvSpPr>
+          <p:cNvPr id="2" name="Text 0"/>
+          <p:cNvSpPr/>
+          <p:nvPr/>
+        </p:nvSpPr>
+        <p:spPr>
+          <a:xfrm>
+            <a:off x="566928" y="6364224"/>
+            <a:ext cx="914400" cy="274320"/>
+          </a:xfrm>
+          <a:prstGeom prst="rect">
+            <a:avLst/>
+          </a:prstGeom>
+          <a:noFill/>
+          <a:ln/>
+        </p:spPr>
+        <p:txBody>
+          <a:bodyPr wrap="square" rtlCol="0" anchor="ctr"/>
+          <a:lstStyle/>
+          <a:p>
+            <a:pPr algn="l" indent="0" marL="0">
+              <a:buNone/>
+            </a:pPr>
+            <a:r>
+              <a:rPr lang="en-US" sz="1000" dirty="0">
+                <a:solidFill>
+                  <a:srgbClr val="8A8A8A"/>
+                </a:solidFill>
+                <a:latin typeface="Red Hat Text" pitchFamily="34" charset="0"/>
+                <a:ea typeface="Red Hat Text" pitchFamily="34" charset="-122"/>
+                <a:cs typeface="Red Hat Text" pitchFamily="34" charset="-120"/>
+              </a:rPr>
+              <a:t>34</a:t>
+            </a:r>
+            <a:endParaRPr lang="en-US" sz="1000" dirty="0"/>
+          </a:p>
+        </p:txBody>
+      </p:sp>
+      <p:pic>
+        <p:nvPicPr>
+          <p:cNvPr id="3" name="Image 0" descr="./assets/logo-candidate-2.png">    </p:cNvPr>
+          <p:cNvPicPr>
+            <a:picLocks noChangeAspect="1"/>
+          </p:cNvPicPr>
+          <p:nvPr/>
+        </p:nvPicPr>
+        <p:blipFill>
+          <a:blip r:embed="rId1"/>
+          <a:stretch>
+            <a:fillRect/>
+          </a:stretch>
+        </p:blipFill>
+        <p:spPr>
+          <a:xfrm>
+            <a:off x="10561320" y="6355080"/>
+            <a:ext cx="1033272" cy="246888"/>
+          </a:xfrm>
+          <a:prstGeom prst="rect">
+            <a:avLst/>
+          </a:prstGeom>
+        </p:spPr>
+      </p:pic>
+      <p:sp>
+        <p:nvSpPr>
+          <p:cNvPr id="4" name="Text 1"/>
+          <p:cNvSpPr/>
+          <p:nvPr/>
+        </p:nvSpPr>
+        <p:spPr>
+          <a:xfrm>
+            <a:off x="566928" y="384048"/>
+            <a:ext cx="11055096" cy="292608"/>
+          </a:xfrm>
+          <a:prstGeom prst="rect">
+            <a:avLst/>
+          </a:prstGeom>
+          <a:noFill/>
+          <a:ln/>
+        </p:spPr>
+        <p:txBody>
+          <a:bodyPr wrap="square" rtlCol="0" anchor="ctr"/>
+          <a:lstStyle/>
+          <a:p>
+            <a:pPr algn="l" indent="0" marL="0">
+              <a:buNone/>
+            </a:pPr>
+            <a:r>
+              <a:rPr lang="en-US" sz="1200" b="1" spc="400" kern="0" dirty="0">
+                <a:solidFill>
+                  <a:srgbClr val="EE0000"/>
+                </a:solidFill>
+                <a:latin typeface="Overpass" pitchFamily="34" charset="0"/>
+                <a:ea typeface="Overpass" pitchFamily="34" charset="-122"/>
+                <a:cs typeface="Overpass" pitchFamily="34" charset="-120"/>
+              </a:rPr>
+              <a:t>SUPPLY CHAIN · ATTACK VECTORS</a:t>
+            </a:r>
+            <a:endParaRPr lang="en-US" sz="1200" dirty="0"/>
+          </a:p>
+        </p:txBody>
+      </p:sp>
+      <p:sp>
+        <p:nvSpPr>
+          <p:cNvPr id="5" name="Text 2"/>
+          <p:cNvSpPr/>
+          <p:nvPr/>
+        </p:nvSpPr>
+        <p:spPr>
+          <a:xfrm>
+            <a:off x="566928" y="676656"/>
+            <a:ext cx="11055096" cy="1005840"/>
+          </a:xfrm>
+          <a:prstGeom prst="rect">
+            <a:avLst/>
+          </a:prstGeom>
+          <a:noFill/>
+          <a:ln/>
+        </p:spPr>
+        <p:txBody>
+          <a:bodyPr wrap="square" rtlCol="0" anchor="t"/>
+          <a:lstStyle/>
+          <a:p>
+            <a:pPr algn="l" indent="0" marL="0">
+              <a:buNone/>
+            </a:pPr>
+            <a:r>
+              <a:rPr lang="en-US" sz="3000" b="1" dirty="0">
+                <a:solidFill>
+                  <a:srgbClr val="151515"/>
+                </a:solidFill>
+                <a:latin typeface="Overpass" pitchFamily="34" charset="0"/>
+                <a:ea typeface="Overpass" pitchFamily="34" charset="-122"/>
+                <a:cs typeface="Overpass" pitchFamily="34" charset="-120"/>
+              </a:rPr>
+              <a:t>The chain, and where it's attacked</a:t>
+            </a:r>
+            <a:endParaRPr lang="en-US" sz="3000" dirty="0"/>
+          </a:p>
+        </p:txBody>
+      </p:sp>
+      <p:pic>
+        <p:nvPicPr>
+          <p:cNvPr id="6" name="Image 1" descr="./png/18-supply-chain-security-attack-vectors.png">    </p:cNvPr>
+          <p:cNvPicPr>
+            <a:picLocks noChangeAspect="1"/>
+          </p:cNvPicPr>
+          <p:nvPr/>
+        </p:nvPicPr>
+        <p:blipFill>
+          <a:blip r:embed="rId2"/>
+          <a:srcRect l="0" r="0" t="0" b="0"/>
+          <a:stretch/>
+        </p:blipFill>
+        <p:spPr>
+          <a:xfrm>
+            <a:off x="1645920" y="1600200"/>
+            <a:ext cx="8906256" cy="4343400"/>
+          </a:xfrm>
+          <a:prstGeom prst="rect">
+            <a:avLst/>
+          </a:prstGeom>
+        </p:spPr>
+      </p:pic>
+      <p:sp>
+        <p:nvSpPr>
+          <p:cNvPr id="7" name="Text 3"/>
+          <p:cNvSpPr/>
+          <p:nvPr/>
+        </p:nvSpPr>
+        <p:spPr>
+          <a:xfrm>
+            <a:off x="566928" y="5943600"/>
+            <a:ext cx="11055096" cy="310896"/>
+          </a:xfrm>
+          <a:prstGeom prst="rect">
+            <a:avLst/>
+          </a:prstGeom>
+          <a:noFill/>
+          <a:ln/>
+        </p:spPr>
+        <p:txBody>
+          <a:bodyPr wrap="square" rtlCol="0" anchor="ctr"/>
+          <a:lstStyle/>
+          <a:p>
+            <a:pPr algn="ctr" indent="0" marL="0">
+              <a:buNone/>
+            </a:pPr>
+            <a:r>
+              <a:rPr lang="en-US" sz="1300" i="1" dirty="0">
+                <a:solidFill>
+                  <a:srgbClr val="5A5A5A"/>
+                </a:solidFill>
+                <a:latin typeface="Red Hat Text" pitchFamily="34" charset="0"/>
+                <a:ea typeface="Red Hat Text" pitchFamily="34" charset="-122"/>
+                <a:cs typeface="Red Hat Text" pitchFamily="34" charset="-120"/>
+              </a:rPr>
+              <a:t>Figure 18.1 — Attack vectors (after Liz Rice, Container Security 2e, Fig 7-1) and the Hummingbird answer at each stage.</a:t>
+            </a:r>
+            <a:endParaRPr lang="en-US" sz="1300" dirty="0"/>
+          </a:p>
+        </p:txBody>
+      </p:sp>
+    </p:spTree>
+  </p:cSld>
+  <p:clrMapOvr>
+    <a:masterClrMapping/>
+  </p:clrMapOvr>
+</p:sld>
+</file>
+
+<file path=ppt/slides/slide35.xml><?xml version="1.0" encoding="utf-8"?>
+<p:sld xmlns:a="http://schemas.openxmlformats.org/drawingml/2006/main" xmlns:r="http://schemas.openxmlformats.org/officeDocument/2006/relationships" xmlns:p="http://schemas.openxmlformats.org/presentationml/2006/main">
+  <p:cSld name="Slide 35">
+    <p:spTree>
+      <p:nvGrpSpPr>
+        <p:cNvPr id="1" name=""/>
+        <p:cNvGrpSpPr/>
+        <p:nvPr/>
+      </p:nvGrpSpPr>
+      <p:grpSpPr>
+        <a:xfrm>
+          <a:off x="0" y="0"/>
+          <a:ext cx="0" cy="0"/>
+          <a:chOff x="0" y="0"/>
+          <a:chExt cx="0" cy="0"/>
+        </a:xfrm>
+      </p:grpSpPr>
+      <p:sp>
+        <p:nvSpPr>
+          <p:cNvPr id="2" name="Text 0"/>
+          <p:cNvSpPr/>
+          <p:nvPr/>
+        </p:nvSpPr>
+        <p:spPr>
+          <a:xfrm>
+            <a:off x="566928" y="6364224"/>
+            <a:ext cx="914400" cy="274320"/>
+          </a:xfrm>
+          <a:prstGeom prst="rect">
+            <a:avLst/>
+          </a:prstGeom>
+          <a:noFill/>
+          <a:ln/>
+        </p:spPr>
+        <p:txBody>
+          <a:bodyPr wrap="square" rtlCol="0" anchor="ctr"/>
+          <a:lstStyle/>
+          <a:p>
+            <a:pPr algn="l" indent="0" marL="0">
+              <a:buNone/>
+            </a:pPr>
+            <a:r>
+              <a:rPr lang="en-US" sz="1000" dirty="0">
+                <a:solidFill>
+                  <a:srgbClr val="8A8A8A"/>
+                </a:solidFill>
+                <a:latin typeface="Red Hat Text" pitchFamily="34" charset="0"/>
+                <a:ea typeface="Red Hat Text" pitchFamily="34" charset="-122"/>
+                <a:cs typeface="Red Hat Text" pitchFamily="34" charset="-120"/>
+              </a:rPr>
+              <a:t>35</a:t>
+            </a:r>
+            <a:endParaRPr lang="en-US" sz="1000" dirty="0"/>
+          </a:p>
+        </p:txBody>
+      </p:sp>
+      <p:pic>
+        <p:nvPicPr>
+          <p:cNvPr id="3" name="Image 0" descr="./assets/logo-candidate-2.png">    </p:cNvPr>
+          <p:cNvPicPr>
+            <a:picLocks noChangeAspect="1"/>
+          </p:cNvPicPr>
+          <p:nvPr/>
+        </p:nvPicPr>
+        <p:blipFill>
+          <a:blip r:embed="rId1"/>
+          <a:stretch>
+            <a:fillRect/>
+          </a:stretch>
+        </p:blipFill>
+        <p:spPr>
+          <a:xfrm>
+            <a:off x="10561320" y="6355080"/>
+            <a:ext cx="1033272" cy="246888"/>
+          </a:xfrm>
+          <a:prstGeom prst="rect">
+            <a:avLst/>
+          </a:prstGeom>
+        </p:spPr>
+      </p:pic>
+      <p:sp>
+        <p:nvSpPr>
+          <p:cNvPr id="4" name="Text 1"/>
+          <p:cNvSpPr/>
+          <p:nvPr/>
+        </p:nvSpPr>
+        <p:spPr>
+          <a:xfrm>
+            <a:off x="566928" y="384048"/>
+            <a:ext cx="11055096" cy="292608"/>
+          </a:xfrm>
+          <a:prstGeom prst="rect">
+            <a:avLst/>
+          </a:prstGeom>
+          <a:noFill/>
+          <a:ln/>
+        </p:spPr>
+        <p:txBody>
+          <a:bodyPr wrap="square" rtlCol="0" anchor="ctr"/>
+          <a:lstStyle/>
+          <a:p>
+            <a:pPr algn="l" indent="0" marL="0">
+              <a:buNone/>
+            </a:pPr>
+            <a:r>
+              <a:rPr lang="en-US" sz="1200" b="1" spc="400" kern="0" dirty="0">
+                <a:solidFill>
+                  <a:srgbClr val="EE0000"/>
+                </a:solidFill>
+                <a:latin typeface="Overpass" pitchFamily="34" charset="0"/>
+                <a:ea typeface="Overpass" pitchFamily="34" charset="-122"/>
+                <a:cs typeface="Overpass" pitchFamily="34" charset="-120"/>
+              </a:rPr>
+              <a:t>SUPPLY CHAIN · RUNTIME SURFACE</a:t>
+            </a:r>
+            <a:endParaRPr lang="en-US" sz="1200" dirty="0"/>
+          </a:p>
+        </p:txBody>
+      </p:sp>
+      <p:sp>
+        <p:nvSpPr>
+          <p:cNvPr id="5" name="Text 2"/>
+          <p:cNvSpPr/>
+          <p:nvPr/>
+        </p:nvSpPr>
+        <p:spPr>
+          <a:xfrm>
+            <a:off x="566928" y="676656"/>
+            <a:ext cx="11055096" cy="1005840"/>
+          </a:xfrm>
+          <a:prstGeom prst="rect">
+            <a:avLst/>
+          </a:prstGeom>
+          <a:noFill/>
+          <a:ln/>
+        </p:spPr>
+        <p:txBody>
+          <a:bodyPr wrap="square" rtlCol="0" anchor="t"/>
+          <a:lstStyle/>
+          <a:p>
+            <a:pPr algn="l" indent="0" marL="0">
+              <a:buNone/>
+            </a:pPr>
+            <a:r>
+              <a:rPr lang="en-US" sz="3000" b="1" dirty="0">
+                <a:solidFill>
+                  <a:srgbClr val="151515"/>
+                </a:solidFill>
+                <a:latin typeface="Overpass" pitchFamily="34" charset="0"/>
+                <a:ea typeface="Overpass" pitchFamily="34" charset="-122"/>
+                <a:cs typeface="Overpass" pitchFamily="34" charset="-120"/>
+              </a:rPr>
+              <a:t>Defense in depth — and where the image helps</a:t>
+            </a:r>
+            <a:endParaRPr lang="en-US" sz="3000" dirty="0"/>
+          </a:p>
+        </p:txBody>
+      </p:sp>
+      <p:pic>
+        <p:nvPicPr>
+          <p:cNvPr id="6" name="Image 1" descr="./png/18-supply-chain-security-layers.png">    </p:cNvPr>
+          <p:cNvPicPr>
+            <a:picLocks noChangeAspect="1"/>
+          </p:cNvPicPr>
+          <p:nvPr/>
+        </p:nvPicPr>
+        <p:blipFill>
+          <a:blip r:embed="rId2"/>
+          <a:srcRect l="0" r="0" t="0" b="0"/>
+          <a:stretch/>
+        </p:blipFill>
+        <p:spPr>
+          <a:xfrm>
+            <a:off x="1645920" y="1600200"/>
+            <a:ext cx="8906256" cy="4343400"/>
+          </a:xfrm>
+          <a:prstGeom prst="rect">
+            <a:avLst/>
+          </a:prstGeom>
+        </p:spPr>
+      </p:pic>
+      <p:sp>
+        <p:nvSpPr>
+          <p:cNvPr id="7" name="Text 3"/>
+          <p:cNvSpPr/>
+          <p:nvPr/>
+        </p:nvSpPr>
+        <p:spPr>
+          <a:xfrm>
+            <a:off x="566928" y="5943600"/>
+            <a:ext cx="11055096" cy="310896"/>
+          </a:xfrm>
+          <a:prstGeom prst="rect">
+            <a:avLst/>
+          </a:prstGeom>
+          <a:noFill/>
+          <a:ln/>
+        </p:spPr>
+        <p:txBody>
+          <a:bodyPr wrap="square" rtlCol="0" anchor="ctr"/>
+          <a:lstStyle/>
+          <a:p>
+            <a:pPr algn="ctr" indent="0" marL="0">
+              <a:buNone/>
+            </a:pPr>
+            <a:r>
+              <a:rPr lang="en-US" sz="1300" i="1" dirty="0">
+                <a:solidFill>
+                  <a:srgbClr val="5A5A5A"/>
+                </a:solidFill>
+                <a:latin typeface="Red Hat Text" pitchFamily="34" charset="0"/>
+                <a:ea typeface="Red Hat Text" pitchFamily="34" charset="-122"/>
+                <a:cs typeface="Red Hat Text" pitchFamily="34" charset="-120"/>
+              </a:rPr>
+              <a:t>Figure 18.2 — The layered runtime attack surface; the hardened image shrinks the image-and-app cluster, not the platform.</a:t>
+            </a:r>
+            <a:endParaRPr lang="en-US" sz="1300" dirty="0"/>
+          </a:p>
+        </p:txBody>
+      </p:sp>
+    </p:spTree>
+  </p:cSld>
+  <p:clrMapOvr>
+    <a:masterClrMapping/>
+  </p:clrMapOvr>
+</p:sld>
+</file>
+
+<file path=ppt/slides/slide36.xml><?xml version="1.0" encoding="utf-8"?>
+<p:sld xmlns:a="http://schemas.openxmlformats.org/drawingml/2006/main" xmlns:r="http://schemas.openxmlformats.org/officeDocument/2006/relationships" xmlns:p="http://schemas.openxmlformats.org/presentationml/2006/main">
+  <p:cSld name="Slide 36">
+    <p:spTree>
+      <p:nvGrpSpPr>
+        <p:cNvPr id="1" name=""/>
+        <p:cNvGrpSpPr/>
+        <p:nvPr/>
+      </p:nvGrpSpPr>
+      <p:grpSpPr>
+        <a:xfrm>
+          <a:off x="0" y="0"/>
+          <a:ext cx="0" cy="0"/>
+          <a:chOff x="0" y="0"/>
+          <a:chExt cx="0" cy="0"/>
+        </a:xfrm>
+      </p:grpSpPr>
+      <p:sp>
+        <p:nvSpPr>
+          <p:cNvPr id="2" name="Text 0"/>
+          <p:cNvSpPr/>
+          <p:nvPr/>
+        </p:nvSpPr>
+        <p:spPr>
+          <a:xfrm>
+            <a:off x="566928" y="6364224"/>
+            <a:ext cx="914400" cy="274320"/>
+          </a:xfrm>
+          <a:prstGeom prst="rect">
+            <a:avLst/>
+          </a:prstGeom>
+          <a:noFill/>
+          <a:ln/>
+        </p:spPr>
+        <p:txBody>
+          <a:bodyPr wrap="square" rtlCol="0" anchor="ctr"/>
+          <a:lstStyle/>
+          <a:p>
+            <a:pPr algn="l" indent="0" marL="0">
+              <a:buNone/>
+            </a:pPr>
+            <a:r>
+              <a:rPr lang="en-US" sz="1000" dirty="0">
+                <a:solidFill>
+                  <a:srgbClr val="8A8A8A"/>
+                </a:solidFill>
+                <a:latin typeface="Red Hat Text" pitchFamily="34" charset="0"/>
+                <a:ea typeface="Red Hat Text" pitchFamily="34" charset="-122"/>
+                <a:cs typeface="Red Hat Text" pitchFamily="34" charset="-120"/>
+              </a:rPr>
+              <a:t>36</a:t>
+            </a:r>
+            <a:endParaRPr lang="en-US" sz="1000" dirty="0"/>
+          </a:p>
+        </p:txBody>
+      </p:sp>
+      <p:pic>
+        <p:nvPicPr>
+          <p:cNvPr id="3" name="Image 0" descr="./assets/logo-candidate-2.png">    </p:cNvPr>
+          <p:cNvPicPr>
+            <a:picLocks noChangeAspect="1"/>
+          </p:cNvPicPr>
+          <p:nvPr/>
+        </p:nvPicPr>
+        <p:blipFill>
+          <a:blip r:embed="rId1"/>
+          <a:stretch>
+            <a:fillRect/>
+          </a:stretch>
+        </p:blipFill>
+        <p:spPr>
+          <a:xfrm>
+            <a:off x="10561320" y="6355080"/>
+            <a:ext cx="1033272" cy="246888"/>
+          </a:xfrm>
+          <a:prstGeom prst="rect">
+            <a:avLst/>
+          </a:prstGeom>
+        </p:spPr>
+      </p:pic>
+      <p:sp>
+        <p:nvSpPr>
+          <p:cNvPr id="4" name="Text 1"/>
+          <p:cNvSpPr/>
+          <p:nvPr/>
+        </p:nvSpPr>
+        <p:spPr>
+          <a:xfrm>
+            <a:off x="566928" y="384048"/>
+            <a:ext cx="11055096" cy="292608"/>
+          </a:xfrm>
+          <a:prstGeom prst="rect">
+            <a:avLst/>
+          </a:prstGeom>
+          <a:noFill/>
+          <a:ln/>
+        </p:spPr>
+        <p:txBody>
+          <a:bodyPr wrap="square" rtlCol="0" anchor="ctr"/>
+          <a:lstStyle/>
+          <a:p>
+            <a:pPr algn="l" indent="0" marL="0">
+              <a:buNone/>
+            </a:pPr>
+            <a:r>
+              <a:rPr lang="en-US" sz="1200" b="1" spc="400" kern="0" dirty="0">
+                <a:solidFill>
+                  <a:srgbClr val="EE0000"/>
+                </a:solidFill>
+                <a:latin typeface="Overpass" pitchFamily="34" charset="0"/>
+                <a:ea typeface="Overpass" pitchFamily="34" charset="-122"/>
+                <a:cs typeface="Overpass" pitchFamily="34" charset="-120"/>
+              </a:rPr>
+              <a:t>SUPPLY CHAIN · DIVISION OF LABOUR</a:t>
+            </a:r>
+            <a:endParaRPr lang="en-US" sz="1200" dirty="0"/>
+          </a:p>
+        </p:txBody>
+      </p:sp>
+      <p:sp>
+        <p:nvSpPr>
+          <p:cNvPr id="5" name="Text 2"/>
+          <p:cNvSpPr/>
+          <p:nvPr/>
+        </p:nvSpPr>
+        <p:spPr>
+          <a:xfrm>
+            <a:off x="566928" y="676656"/>
+            <a:ext cx="11055096" cy="1005840"/>
+          </a:xfrm>
+          <a:prstGeom prst="rect">
+            <a:avLst/>
+          </a:prstGeom>
+          <a:noFill/>
+          <a:ln/>
+        </p:spPr>
+        <p:txBody>
+          <a:bodyPr wrap="square" rtlCol="0" anchor="t"/>
+          <a:lstStyle/>
+          <a:p>
+            <a:pPr algn="l" indent="0" marL="0">
+              <a:buNone/>
+            </a:pPr>
+            <a:r>
+              <a:rPr lang="en-US" sz="3000" b="1" dirty="0">
+                <a:solidFill>
+                  <a:srgbClr val="151515"/>
+                </a:solidFill>
+                <a:latin typeface="Overpass" pitchFamily="34" charset="0"/>
+                <a:ea typeface="Overpass" pitchFamily="34" charset="-122"/>
+                <a:cs typeface="Overpass" pitchFamily="34" charset="-120"/>
+              </a:rPr>
+              <a:t>What Hummingbird closes — and what's still yours</a:t>
+            </a:r>
+            <a:endParaRPr lang="en-US" sz="3000" dirty="0"/>
+          </a:p>
+        </p:txBody>
+      </p:sp>
+      <p:graphicFrame>
+        <p:nvGraphicFramePr>
+          <p:cNvPr id="37" name="Table 0"/>
+          <p:cNvGraphicFramePr>
+            <a:graphicFrameLocks noGrp="1"/>
+          </p:cNvGraphicFramePr>
+          <p:nvPr>
+            <p:extLst>
+              <p:ext uri="{D42A27DB-BD31-4B8C-83A1-F6EECF244321}">
+                <p14:modId xmlns:p14="http://schemas.microsoft.com/office/powerpoint/2010/main" val="1579011935"/>
+              </p:ext>
+            </p:extLst>
+          </p:nvPr>
+        </p:nvGraphicFramePr>
+        <p:xfrm>
+          <a:off x="566928" y="1691640"/>
+          <a:ext cx="11055096" cy="4434840"/>
+        </p:xfrm>
+        <a:graphic>
+          <a:graphicData uri="http://schemas.openxmlformats.org/drawingml/2006/table">
+            <a:tbl>
+              <a:tblPr/>
+              <a:tblGrid>
+                <a:gridCol w="2514600"/>
+                <a:gridCol w="2606040"/>
+                <a:gridCol w="5934456"/>
+              </a:tblGrid>
+              <a:tr h="566928">
+                <a:tc>
+                  <a:txBody>
+                    <a:bodyPr/>
+                    <a:lstStyle/>
+                    <a:p>
+                      <a:pPr algn="l" indent="0" marL="0">
+                        <a:buNone/>
+                      </a:pPr>
+                      <a:r>
+                        <a:rPr lang="en-US" sz="1500" b="1" dirty="0">
+                          <a:solidFill>
+                            <a:srgbClr val="EE0000"/>
+                          </a:solidFill>
+                          <a:latin typeface="Red Hat Mono" pitchFamily="34" charset="0"/>
+                          <a:ea typeface="Red Hat Mono" pitchFamily="34" charset="-122"/>
+                          <a:cs typeface="Red Hat Mono" pitchFamily="34" charset="-120"/>
+                        </a:rPr>
+                        <a:t>Vulnerable base</a:t>
+                      </a:r>
+                      <a:endParaRPr lang="en-US" sz="1500" dirty="0">
+                        <a:latin typeface="Red Hat Mono" charset="0"/>
+                        <a:ea typeface="Red Hat Mono" charset="0"/>
+                        <a:cs typeface="Red Hat Mono" charset="0"/>
+                      </a:endParaRPr>
+                    </a:p>
+                  </a:txBody>
+                  <a:tcPr marL="91440" marR="91440" marT="45720" marB="45720" anchor="ctr">
+                    <a:lnL w="6350" cap="flat" cmpd="sng" algn="ctr">
+                      <a:solidFill>
+                        <a:srgbClr val="D2D2D2"/>
+                      </a:solidFill>
+                      <a:prstDash val="solid"/>
+                      <a:round/>
+                      <a:headEnd type="none" w="med" len="med"/>
+                      <a:tailEnd type="none" w="med" len="med"/>
+                    </a:lnL>
+                    <a:lnR w="6350" cap="flat" cmpd="sng" algn="ctr">
+                      <a:solidFill>
+                        <a:srgbClr val="D2D2D2"/>
+                      </a:solidFill>
+                      <a:prstDash val="solid"/>
+                      <a:round/>
+                      <a:headEnd type="none" w="med" len="med"/>
+                      <a:tailEnd type="none" w="med" len="med"/>
+                    </a:lnR>
+                    <a:lnT w="6350" cap="flat" cmpd="sng" algn="ctr">
+                      <a:solidFill>
+                        <a:srgbClr val="D2D2D2"/>
+                      </a:solidFill>
+                      <a:prstDash val="solid"/>
+                      <a:round/>
+                      <a:headEnd type="none" w="med" len="med"/>
+                      <a:tailEnd type="none" w="med" len="med"/>
+                    </a:lnT>
+                    <a:lnB w="6350" cap="flat" cmpd="sng" algn="ctr">
+                      <a:solidFill>
+                        <a:srgbClr val="D2D2D2"/>
+                      </a:solidFill>
+                      <a:prstDash val="solid"/>
+                      <a:round/>
+                      <a:headEnd type="none" w="med" len="med"/>
+                      <a:tailEnd type="none" w="med" len="med"/>
+                    </a:lnB>
+                  </a:tcPr>
+                </a:tc>
+                <a:tc>
+                  <a:txBody>
+                    <a:bodyPr/>
+                    <a:lstStyle/>
+                    <a:p>
+                      <a:pPr algn="l" indent="0" marL="0">
+                        <a:buNone/>
+                      </a:pPr>
+                      <a:r>
+                        <a:rPr lang="en-US" sz="1400" b="1" dirty="0">
+                          <a:solidFill>
+                            <a:srgbClr val="151515"/>
+                          </a:solidFill>
+                          <a:latin typeface="Red Hat Text" pitchFamily="34" charset="0"/>
+                          <a:ea typeface="Red Hat Text" pitchFamily="34" charset="-122"/>
+                          <a:cs typeface="Red Hat Text" pitchFamily="34" charset="-120"/>
+                        </a:rPr>
+                        <a:t>Hummingbird</a:t>
+                      </a:r>
+                      <a:endParaRPr lang="en-US" sz="1400" dirty="0">
+                        <a:latin typeface="Red Hat Text" charset="0"/>
+                        <a:ea typeface="Red Hat Text" charset="0"/>
+                        <a:cs typeface="Red Hat Text" charset="0"/>
+                      </a:endParaRPr>
+                    </a:p>
+                  </a:txBody>
+                  <a:tcPr marL="91440" marR="91440" marT="45720" marB="45720" anchor="ctr">
+                    <a:lnL w="6350" cap="flat" cmpd="sng" algn="ctr">
+                      <a:solidFill>
+                        <a:srgbClr val="D2D2D2"/>
+                      </a:solidFill>
+                      <a:prstDash val="solid"/>
+                      <a:round/>
+                      <a:headEnd type="none" w="med" len="med"/>
+                      <a:tailEnd type="none" w="med" len="med"/>
+                    </a:lnL>
+                    <a:lnR w="6350" cap="flat" cmpd="sng" algn="ctr">
+                      <a:solidFill>
+                        <a:srgbClr val="D2D2D2"/>
+                      </a:solidFill>
+                      <a:prstDash val="solid"/>
+                      <a:round/>
+                      <a:headEnd type="none" w="med" len="med"/>
+                      <a:tailEnd type="none" w="med" len="med"/>
+                    </a:lnR>
+                    <a:lnT w="6350" cap="flat" cmpd="sng" algn="ctr">
+                      <a:solidFill>
+                        <a:srgbClr val="D2D2D2"/>
+                      </a:solidFill>
+                      <a:prstDash val="solid"/>
+                      <a:round/>
+                      <a:headEnd type="none" w="med" len="med"/>
+                      <a:tailEnd type="none" w="med" len="med"/>
+                    </a:lnT>
+                    <a:lnB w="6350" cap="flat" cmpd="sng" algn="ctr">
+                      <a:solidFill>
+                        <a:srgbClr val="D2D2D2"/>
+                      </a:solidFill>
+                      <a:prstDash val="solid"/>
+                      <a:round/>
+                      <a:headEnd type="none" w="med" len="med"/>
+                      <a:tailEnd type="none" w="med" len="med"/>
+                    </a:lnB>
+                  </a:tcPr>
+                </a:tc>
+                <a:tc>
+                  <a:txBody>
+                    <a:bodyPr/>
+                    <a:lstStyle/>
+                    <a:p>
+                      <a:pPr algn="l" indent="0" marL="0">
+                        <a:buNone/>
+                      </a:pPr>
+                      <a:r>
+                        <a:rPr lang="en-US" sz="1300" dirty="0">
+                          <a:solidFill>
+                            <a:srgbClr val="242424"/>
+                          </a:solidFill>
+                          <a:latin typeface="Red Hat Text" pitchFamily="34" charset="0"/>
+                          <a:ea typeface="Red Hat Text" pitchFamily="34" charset="-122"/>
+                          <a:cs typeface="Red Hat Text" pitchFamily="34" charset="-120"/>
+                        </a:rPr>
+                        <a:t>Near-zero-CVE hardened base, rebuilt continuously</a:t>
+                      </a:r>
+                      <a:endParaRPr lang="en-US" sz="1300" dirty="0">
+                        <a:latin typeface="Red Hat Text" charset="0"/>
+                        <a:ea typeface="Red Hat Text" charset="0"/>
+                        <a:cs typeface="Red Hat Text" charset="0"/>
+                      </a:endParaRPr>
+                    </a:p>
+                  </a:txBody>
+                  <a:tcPr marL="91440" marR="91440" marT="45720" marB="45720" anchor="ctr">
+                    <a:lnL w="6350" cap="flat" cmpd="sng" algn="ctr">
+                      <a:solidFill>
+                        <a:srgbClr val="D2D2D2"/>
+                      </a:solidFill>
+                      <a:prstDash val="solid"/>
+                      <a:round/>
+                      <a:headEnd type="none" w="med" len="med"/>
+                      <a:tailEnd type="none" w="med" len="med"/>
+                    </a:lnL>
+                    <a:lnR w="6350" cap="flat" cmpd="sng" algn="ctr">
+                      <a:solidFill>
+                        <a:srgbClr val="D2D2D2"/>
+                      </a:solidFill>
+                      <a:prstDash val="solid"/>
+                      <a:round/>
+                      <a:headEnd type="none" w="med" len="med"/>
+                      <a:tailEnd type="none" w="med" len="med"/>
+                    </a:lnR>
+                    <a:lnT w="6350" cap="flat" cmpd="sng" algn="ctr">
+                      <a:solidFill>
+                        <a:srgbClr val="D2D2D2"/>
+                      </a:solidFill>
+                      <a:prstDash val="solid"/>
+                      <a:round/>
+                      <a:headEnd type="none" w="med" len="med"/>
+                      <a:tailEnd type="none" w="med" len="med"/>
+                    </a:lnT>
+                    <a:lnB w="6350" cap="flat" cmpd="sng" algn="ctr">
+                      <a:solidFill>
+                        <a:srgbClr val="D2D2D2"/>
+                      </a:solidFill>
+                      <a:prstDash val="solid"/>
+                      <a:round/>
+                      <a:headEnd type="none" w="med" len="med"/>
+                      <a:tailEnd type="none" w="med" len="med"/>
+                    </a:lnB>
+                  </a:tcPr>
+                </a:tc>
+              </a:tr>
+              <a:tr h="566928">
+                <a:tc>
+                  <a:txBody>
+                    <a:bodyPr/>
+                    <a:lstStyle/>
+                    <a:p>
+                      <a:pPr algn="l" indent="0" marL="0">
+                        <a:buNone/>
+                      </a:pPr>
+                      <a:r>
+                        <a:rPr lang="en-US" sz="1500" b="1" dirty="0">
+                          <a:solidFill>
+                            <a:srgbClr val="EE0000"/>
+                          </a:solidFill>
+                          <a:latin typeface="Red Hat Mono" pitchFamily="34" charset="0"/>
+                          <a:ea typeface="Red Hat Mono" pitchFamily="34" charset="-122"/>
+                          <a:cs typeface="Red Hat Mono" pitchFamily="34" charset="-120"/>
+                        </a:rPr>
+                        <a:t>Vulnerable deps</a:t>
+                      </a:r>
+                      <a:endParaRPr lang="en-US" sz="1500" dirty="0">
+                        <a:latin typeface="Red Hat Mono" charset="0"/>
+                        <a:ea typeface="Red Hat Mono" charset="0"/>
+                        <a:cs typeface="Red Hat Mono" charset="0"/>
+                      </a:endParaRPr>
+                    </a:p>
+                  </a:txBody>
+                  <a:tcPr marL="91440" marR="91440" marT="45720" marB="45720" anchor="ctr">
+                    <a:lnL w="6350" cap="flat" cmpd="sng" algn="ctr">
+                      <a:solidFill>
+                        <a:srgbClr val="D2D2D2"/>
+                      </a:solidFill>
+                      <a:prstDash val="solid"/>
+                      <a:round/>
+                      <a:headEnd type="none" w="med" len="med"/>
+                      <a:tailEnd type="none" w="med" len="med"/>
+                    </a:lnL>
+                    <a:lnR w="6350" cap="flat" cmpd="sng" algn="ctr">
+                      <a:solidFill>
+                        <a:srgbClr val="D2D2D2"/>
+                      </a:solidFill>
+                      <a:prstDash val="solid"/>
+                      <a:round/>
+                      <a:headEnd type="none" w="med" len="med"/>
+                      <a:tailEnd type="none" w="med" len="med"/>
+                    </a:lnR>
+                    <a:lnT w="6350" cap="flat" cmpd="sng" algn="ctr">
+                      <a:solidFill>
+                        <a:srgbClr val="D2D2D2"/>
+                      </a:solidFill>
+                      <a:prstDash val="solid"/>
+                      <a:round/>
+                      <a:headEnd type="none" w="med" len="med"/>
+                      <a:tailEnd type="none" w="med" len="med"/>
+                    </a:lnT>
+                    <a:lnB w="6350" cap="flat" cmpd="sng" algn="ctr">
+                      <a:solidFill>
+                        <a:srgbClr val="D2D2D2"/>
+                      </a:solidFill>
+                      <a:prstDash val="solid"/>
+                      <a:round/>
+                      <a:headEnd type="none" w="med" len="med"/>
+                      <a:tailEnd type="none" w="med" len="med"/>
+                    </a:lnB>
+                  </a:tcPr>
+                </a:tc>
+                <a:tc>
+                  <a:txBody>
+                    <a:bodyPr/>
+                    <a:lstStyle/>
+                    <a:p>
+                      <a:pPr algn="l" indent="0" marL="0">
+                        <a:buNone/>
+                      </a:pPr>
+                      <a:r>
+                        <a:rPr lang="en-US" sz="1400" b="1" dirty="0">
+                          <a:solidFill>
+                            <a:srgbClr val="151515"/>
+                          </a:solidFill>
+                          <a:latin typeface="Red Hat Text" pitchFamily="34" charset="0"/>
+                          <a:ea typeface="Red Hat Text" pitchFamily="34" charset="-122"/>
+                          <a:cs typeface="Red Hat Text" pitchFamily="34" charset="-120"/>
+                        </a:rPr>
+                        <a:t>Hummingbird + TL</a:t>
+                      </a:r>
+                      <a:endParaRPr lang="en-US" sz="1400" dirty="0">
+                        <a:latin typeface="Red Hat Text" charset="0"/>
+                        <a:ea typeface="Red Hat Text" charset="0"/>
+                        <a:cs typeface="Red Hat Text" charset="0"/>
+                      </a:endParaRPr>
+                    </a:p>
+                  </a:txBody>
+                  <a:tcPr marL="91440" marR="91440" marT="45720" marB="45720" anchor="ctr">
+                    <a:lnL w="6350" cap="flat" cmpd="sng" algn="ctr">
+                      <a:solidFill>
+                        <a:srgbClr val="D2D2D2"/>
+                      </a:solidFill>
+                      <a:prstDash val="solid"/>
+                      <a:round/>
+                      <a:headEnd type="none" w="med" len="med"/>
+                      <a:tailEnd type="none" w="med" len="med"/>
+                    </a:lnL>
+                    <a:lnR w="6350" cap="flat" cmpd="sng" algn="ctr">
+                      <a:solidFill>
+                        <a:srgbClr val="D2D2D2"/>
+                      </a:solidFill>
+                      <a:prstDash val="solid"/>
+                      <a:round/>
+                      <a:headEnd type="none" w="med" len="med"/>
+                      <a:tailEnd type="none" w="med" len="med"/>
+                    </a:lnR>
+                    <a:lnT w="6350" cap="flat" cmpd="sng" algn="ctr">
+                      <a:solidFill>
+                        <a:srgbClr val="D2D2D2"/>
+                      </a:solidFill>
+                      <a:prstDash val="solid"/>
+                      <a:round/>
+                      <a:headEnd type="none" w="med" len="med"/>
+                      <a:tailEnd type="none" w="med" len="med"/>
+                    </a:lnT>
+                    <a:lnB w="6350" cap="flat" cmpd="sng" algn="ctr">
+                      <a:solidFill>
+                        <a:srgbClr val="D2D2D2"/>
+                      </a:solidFill>
+                      <a:prstDash val="solid"/>
+                      <a:round/>
+                      <a:headEnd type="none" w="med" len="med"/>
+                      <a:tailEnd type="none" w="med" len="med"/>
+                    </a:lnB>
+                  </a:tcPr>
+                </a:tc>
+                <a:tc>
+                  <a:txBody>
+                    <a:bodyPr/>
+                    <a:lstStyle/>
+                    <a:p>
+                      <a:pPr algn="l" indent="0" marL="0">
+                        <a:buNone/>
+                      </a:pPr>
+                      <a:r>
+                        <a:rPr lang="en-US" sz="1300" dirty="0">
+                          <a:solidFill>
+                            <a:srgbClr val="242424"/>
+                          </a:solidFill>
+                          <a:latin typeface="Red Hat Text" pitchFamily="34" charset="0"/>
+                          <a:ea typeface="Red Hat Text" pitchFamily="34" charset="-122"/>
+                          <a:cs typeface="Red Hat Text" pitchFamily="34" charset="-120"/>
+                        </a:rPr>
+                        <a:t>Distroless minimalism; Trusted Libraries for Python</a:t>
+                      </a:r>
+                      <a:endParaRPr lang="en-US" sz="1300" dirty="0">
+                        <a:latin typeface="Red Hat Text" charset="0"/>
+                        <a:ea typeface="Red Hat Text" charset="0"/>
+                        <a:cs typeface="Red Hat Text" charset="0"/>
+                      </a:endParaRPr>
+                    </a:p>
+                  </a:txBody>
+                  <a:tcPr marL="91440" marR="91440" marT="45720" marB="45720" anchor="ctr">
+                    <a:lnL w="6350" cap="flat" cmpd="sng" algn="ctr">
+                      <a:solidFill>
+                        <a:srgbClr val="D2D2D2"/>
+                      </a:solidFill>
+                      <a:prstDash val="solid"/>
+                      <a:round/>
+                      <a:headEnd type="none" w="med" len="med"/>
+                      <a:tailEnd type="none" w="med" len="med"/>
+                    </a:lnL>
+                    <a:lnR w="6350" cap="flat" cmpd="sng" algn="ctr">
+                      <a:solidFill>
+                        <a:srgbClr val="D2D2D2"/>
+                      </a:solidFill>
+                      <a:prstDash val="solid"/>
+                      <a:round/>
+                      <a:headEnd type="none" w="med" len="med"/>
+                      <a:tailEnd type="none" w="med" len="med"/>
+                    </a:lnR>
+                    <a:lnT w="6350" cap="flat" cmpd="sng" algn="ctr">
+                      <a:solidFill>
+                        <a:srgbClr val="D2D2D2"/>
+                      </a:solidFill>
+                      <a:prstDash val="solid"/>
+                      <a:round/>
+                      <a:headEnd type="none" w="med" len="med"/>
+                      <a:tailEnd type="none" w="med" len="med"/>
+                    </a:lnT>
+                    <a:lnB w="6350" cap="flat" cmpd="sng" algn="ctr">
+                      <a:solidFill>
+                        <a:srgbClr val="D2D2D2"/>
+                      </a:solidFill>
+                      <a:prstDash val="solid"/>
+                      <a:round/>
+                      <a:headEnd type="none" w="med" len="med"/>
+                      <a:tailEnd type="none" w="med" len="med"/>
+                    </a:lnB>
+                  </a:tcPr>
+                </a:tc>
+              </a:tr>
+              <a:tr h="566928">
+                <a:tc>
+                  <a:txBody>
+                    <a:bodyPr/>
+                    <a:lstStyle/>
+                    <a:p>
+                      <a:pPr algn="l" indent="0" marL="0">
+                        <a:buNone/>
+                      </a:pPr>
+                      <a:r>
+                        <a:rPr lang="en-US" sz="1500" b="1" dirty="0">
+                          <a:solidFill>
+                            <a:srgbClr val="EE0000"/>
+                          </a:solidFill>
+                          <a:latin typeface="Red Hat Mono" pitchFamily="34" charset="0"/>
+                          <a:ea typeface="Red Hat Mono" pitchFamily="34" charset="-122"/>
+                          <a:cs typeface="Red Hat Mono" pitchFamily="34" charset="-120"/>
+                        </a:rPr>
+                        <a:t>Build integrity</a:t>
+                      </a:r>
+                      <a:endParaRPr lang="en-US" sz="1500" dirty="0">
+                        <a:latin typeface="Red Hat Mono" charset="0"/>
+                        <a:ea typeface="Red Hat Mono" charset="0"/>
+                        <a:cs typeface="Red Hat Mono" charset="0"/>
+                      </a:endParaRPr>
+                    </a:p>
+                  </a:txBody>
+                  <a:tcPr marL="91440" marR="91440" marT="45720" marB="45720" anchor="ctr">
+                    <a:lnL w="6350" cap="flat" cmpd="sng" algn="ctr">
+                      <a:solidFill>
+                        <a:srgbClr val="D2D2D2"/>
+                      </a:solidFill>
+                      <a:prstDash val="solid"/>
+                      <a:round/>
+                      <a:headEnd type="none" w="med" len="med"/>
+                      <a:tailEnd type="none" w="med" len="med"/>
+                    </a:lnL>
+                    <a:lnR w="6350" cap="flat" cmpd="sng" algn="ctr">
+                      <a:solidFill>
+                        <a:srgbClr val="D2D2D2"/>
+                      </a:solidFill>
+                      <a:prstDash val="solid"/>
+                      <a:round/>
+                      <a:headEnd type="none" w="med" len="med"/>
+                      <a:tailEnd type="none" w="med" len="med"/>
+                    </a:lnR>
+                    <a:lnT w="6350" cap="flat" cmpd="sng" algn="ctr">
+                      <a:solidFill>
+                        <a:srgbClr val="D2D2D2"/>
+                      </a:solidFill>
+                      <a:prstDash val="solid"/>
+                      <a:round/>
+                      <a:headEnd type="none" w="med" len="med"/>
+                      <a:tailEnd type="none" w="med" len="med"/>
+                    </a:lnT>
+                    <a:lnB w="6350" cap="flat" cmpd="sng" algn="ctr">
+                      <a:solidFill>
+                        <a:srgbClr val="D2D2D2"/>
+                      </a:solidFill>
+                      <a:prstDash val="solid"/>
+                      <a:round/>
+                      <a:headEnd type="none" w="med" len="med"/>
+                      <a:tailEnd type="none" w="med" len="med"/>
+                    </a:lnB>
+                  </a:tcPr>
+                </a:tc>
+                <a:tc>
+                  <a:txBody>
+                    <a:bodyPr/>
+                    <a:lstStyle/>
+                    <a:p>
+                      <a:pPr algn="l" indent="0" marL="0">
+                        <a:buNone/>
+                      </a:pPr>
+                      <a:r>
+                        <a:rPr lang="en-US" sz="1400" b="1" dirty="0">
+                          <a:solidFill>
+                            <a:srgbClr val="151515"/>
+                          </a:solidFill>
+                          <a:latin typeface="Red Hat Text" pitchFamily="34" charset="0"/>
+                          <a:ea typeface="Red Hat Text" pitchFamily="34" charset="-122"/>
+                          <a:cs typeface="Red Hat Text" pitchFamily="34" charset="-120"/>
+                        </a:rPr>
+                        <a:t>Hummingbird</a:t>
+                      </a:r>
+                      <a:endParaRPr lang="en-US" sz="1400" dirty="0">
+                        <a:latin typeface="Red Hat Text" charset="0"/>
+                        <a:ea typeface="Red Hat Text" charset="0"/>
+                        <a:cs typeface="Red Hat Text" charset="0"/>
+                      </a:endParaRPr>
+                    </a:p>
+                  </a:txBody>
+                  <a:tcPr marL="91440" marR="91440" marT="45720" marB="45720" anchor="ctr">
+                    <a:lnL w="6350" cap="flat" cmpd="sng" algn="ctr">
+                      <a:solidFill>
+                        <a:srgbClr val="D2D2D2"/>
+                      </a:solidFill>
+                      <a:prstDash val="solid"/>
+                      <a:round/>
+                      <a:headEnd type="none" w="med" len="med"/>
+                      <a:tailEnd type="none" w="med" len="med"/>
+                    </a:lnL>
+                    <a:lnR w="6350" cap="flat" cmpd="sng" algn="ctr">
+                      <a:solidFill>
+                        <a:srgbClr val="D2D2D2"/>
+                      </a:solidFill>
+                      <a:prstDash val="solid"/>
+                      <a:round/>
+                      <a:headEnd type="none" w="med" len="med"/>
+                      <a:tailEnd type="none" w="med" len="med"/>
+                    </a:lnR>
+                    <a:lnT w="6350" cap="flat" cmpd="sng" algn="ctr">
+                      <a:solidFill>
+                        <a:srgbClr val="D2D2D2"/>
+                      </a:solidFill>
+                      <a:prstDash val="solid"/>
+                      <a:round/>
+                      <a:headEnd type="none" w="med" len="med"/>
+                      <a:tailEnd type="none" w="med" len="med"/>
+                    </a:lnT>
+                    <a:lnB w="6350" cap="flat" cmpd="sng" algn="ctr">
+                      <a:solidFill>
+                        <a:srgbClr val="D2D2D2"/>
+                      </a:solidFill>
+                      <a:prstDash val="solid"/>
+                      <a:round/>
+                      <a:headEnd type="none" w="med" len="med"/>
+                      <a:tailEnd type="none" w="med" len="med"/>
+                    </a:lnB>
+                  </a:tcPr>
+                </a:tc>
+                <a:tc>
+                  <a:txBody>
+                    <a:bodyPr/>
+                    <a:lstStyle/>
+                    <a:p>
+                      <a:pPr algn="l" indent="0" marL="0">
+                        <a:buNone/>
+                      </a:pPr>
+                      <a:r>
+                        <a:rPr lang="en-US" sz="1300" dirty="0">
+                          <a:solidFill>
+                            <a:srgbClr val="242424"/>
+                          </a:solidFill>
+                          <a:latin typeface="Red Hat Text" pitchFamily="34" charset="0"/>
+                          <a:ea typeface="Red Hat Text" pitchFamily="34" charset="-122"/>
+                          <a:cs typeface="Red Hat Text" pitchFamily="34" charset="-120"/>
+                        </a:rPr>
+                        <a:t>SLSA 3 hermetic Konflux build, signed provenance</a:t>
+                      </a:r>
+                      <a:endParaRPr lang="en-US" sz="1300" dirty="0">
+                        <a:latin typeface="Red Hat Text" charset="0"/>
+                        <a:ea typeface="Red Hat Text" charset="0"/>
+                        <a:cs typeface="Red Hat Text" charset="0"/>
+                      </a:endParaRPr>
+                    </a:p>
+                  </a:txBody>
+                  <a:tcPr marL="91440" marR="91440" marT="45720" marB="45720" anchor="ctr">
+                    <a:lnL w="6350" cap="flat" cmpd="sng" algn="ctr">
+                      <a:solidFill>
+                        <a:srgbClr val="D2D2D2"/>
+                      </a:solidFill>
+                      <a:prstDash val="solid"/>
+                      <a:round/>
+                      <a:headEnd type="none" w="med" len="med"/>
+                      <a:tailEnd type="none" w="med" len="med"/>
+                    </a:lnL>
+                    <a:lnR w="6350" cap="flat" cmpd="sng" algn="ctr">
+                      <a:solidFill>
+                        <a:srgbClr val="D2D2D2"/>
+                      </a:solidFill>
+                      <a:prstDash val="solid"/>
+                      <a:round/>
+                      <a:headEnd type="none" w="med" len="med"/>
+                      <a:tailEnd type="none" w="med" len="med"/>
+                    </a:lnR>
+                    <a:lnT w="6350" cap="flat" cmpd="sng" algn="ctr">
+                      <a:solidFill>
+                        <a:srgbClr val="D2D2D2"/>
+                      </a:solidFill>
+                      <a:prstDash val="solid"/>
+                      <a:round/>
+                      <a:headEnd type="none" w="med" len="med"/>
+                      <a:tailEnd type="none" w="med" len="med"/>
+                    </a:lnT>
+                    <a:lnB w="6350" cap="flat" cmpd="sng" algn="ctr">
+                      <a:solidFill>
+                        <a:srgbClr val="D2D2D2"/>
+                      </a:solidFill>
+                      <a:prstDash val="solid"/>
+                      <a:round/>
+                      <a:headEnd type="none" w="med" len="med"/>
+                      <a:tailEnd type="none" w="med" len="med"/>
+                    </a:lnB>
+                  </a:tcPr>
+                </a:tc>
+              </a:tr>
+              <a:tr h="566928">
+                <a:tc>
+                  <a:txBody>
+                    <a:bodyPr/>
+                    <a:lstStyle/>
+                    <a:p>
+                      <a:pPr algn="l" indent="0" marL="0">
+                        <a:buNone/>
+                      </a:pPr>
+                      <a:r>
+                        <a:rPr lang="en-US" sz="1500" b="1" dirty="0">
+                          <a:solidFill>
+                            <a:srgbClr val="EE0000"/>
+                          </a:solidFill>
+                          <a:latin typeface="Red Hat Mono" pitchFamily="34" charset="0"/>
+                          <a:ea typeface="Red Hat Mono" pitchFamily="34" charset="-122"/>
+                          <a:cs typeface="Red Hat Mono" pitchFamily="34" charset="-120"/>
+                        </a:rPr>
+                        <a:t>Image authenticity</a:t>
+                      </a:r>
+                      <a:endParaRPr lang="en-US" sz="1500" dirty="0">
+                        <a:latin typeface="Red Hat Mono" charset="0"/>
+                        <a:ea typeface="Red Hat Mono" charset="0"/>
+                        <a:cs typeface="Red Hat Mono" charset="0"/>
+                      </a:endParaRPr>
+                    </a:p>
+                  </a:txBody>
+                  <a:tcPr marL="91440" marR="91440" marT="45720" marB="45720" anchor="ctr">
+                    <a:lnL w="6350" cap="flat" cmpd="sng" algn="ctr">
+                      <a:solidFill>
+                        <a:srgbClr val="D2D2D2"/>
+                      </a:solidFill>
+                      <a:prstDash val="solid"/>
+                      <a:round/>
+                      <a:headEnd type="none" w="med" len="med"/>
+                      <a:tailEnd type="none" w="med" len="med"/>
+                    </a:lnL>
+                    <a:lnR w="6350" cap="flat" cmpd="sng" algn="ctr">
+                      <a:solidFill>
+                        <a:srgbClr val="D2D2D2"/>
+                      </a:solidFill>
+                      <a:prstDash val="solid"/>
+                      <a:round/>
+                      <a:headEnd type="none" w="med" len="med"/>
+                      <a:tailEnd type="none" w="med" len="med"/>
+                    </a:lnR>
+                    <a:lnT w="6350" cap="flat" cmpd="sng" algn="ctr">
+                      <a:solidFill>
+                        <a:srgbClr val="D2D2D2"/>
+                      </a:solidFill>
+                      <a:prstDash val="solid"/>
+                      <a:round/>
+                      <a:headEnd type="none" w="med" len="med"/>
+                      <a:tailEnd type="none" w="med" len="med"/>
+                    </a:lnT>
+                    <a:lnB w="6350" cap="flat" cmpd="sng" algn="ctr">
+                      <a:solidFill>
+                        <a:srgbClr val="D2D2D2"/>
+                      </a:solidFill>
+                      <a:prstDash val="solid"/>
+                      <a:round/>
+                      <a:headEnd type="none" w="med" len="med"/>
+                      <a:tailEnd type="none" w="med" len="med"/>
+                    </a:lnB>
+                  </a:tcPr>
+                </a:tc>
+                <a:tc>
+                  <a:txBody>
+                    <a:bodyPr/>
+                    <a:lstStyle/>
+                    <a:p>
+                      <a:pPr algn="l" indent="0" marL="0">
+                        <a:buNone/>
+                      </a:pPr>
+                      <a:r>
+                        <a:rPr lang="en-US" sz="1400" b="1" dirty="0">
+                          <a:solidFill>
+                            <a:srgbClr val="151515"/>
+                          </a:solidFill>
+                          <a:latin typeface="Red Hat Text" pitchFamily="34" charset="0"/>
+                          <a:ea typeface="Red Hat Text" pitchFamily="34" charset="-122"/>
+                          <a:cs typeface="Red Hat Text" pitchFamily="34" charset="-120"/>
+                        </a:rPr>
+                        <a:t>Hummingbird</a:t>
+                      </a:r>
+                      <a:endParaRPr lang="en-US" sz="1400" dirty="0">
+                        <a:latin typeface="Red Hat Text" charset="0"/>
+                        <a:ea typeface="Red Hat Text" charset="0"/>
+                        <a:cs typeface="Red Hat Text" charset="0"/>
+                      </a:endParaRPr>
+                    </a:p>
+                  </a:txBody>
+                  <a:tcPr marL="91440" marR="91440" marT="45720" marB="45720" anchor="ctr">
+                    <a:lnL w="6350" cap="flat" cmpd="sng" algn="ctr">
+                      <a:solidFill>
+                        <a:srgbClr val="D2D2D2"/>
+                      </a:solidFill>
+                      <a:prstDash val="solid"/>
+                      <a:round/>
+                      <a:headEnd type="none" w="med" len="med"/>
+                      <a:tailEnd type="none" w="med" len="med"/>
+                    </a:lnL>
+                    <a:lnR w="6350" cap="flat" cmpd="sng" algn="ctr">
+                      <a:solidFill>
+                        <a:srgbClr val="D2D2D2"/>
+                      </a:solidFill>
+                      <a:prstDash val="solid"/>
+                      <a:round/>
+                      <a:headEnd type="none" w="med" len="med"/>
+                      <a:tailEnd type="none" w="med" len="med"/>
+                    </a:lnR>
+                    <a:lnT w="6350" cap="flat" cmpd="sng" algn="ctr">
+                      <a:solidFill>
+                        <a:srgbClr val="D2D2D2"/>
+                      </a:solidFill>
+                      <a:prstDash val="solid"/>
+                      <a:round/>
+                      <a:headEnd type="none" w="med" len="med"/>
+                      <a:tailEnd type="none" w="med" len="med"/>
+                    </a:lnT>
+                    <a:lnB w="6350" cap="flat" cmpd="sng" algn="ctr">
+                      <a:solidFill>
+                        <a:srgbClr val="D2D2D2"/>
+                      </a:solidFill>
+                      <a:prstDash val="solid"/>
+                      <a:round/>
+                      <a:headEnd type="none" w="med" len="med"/>
+                      <a:tailEnd type="none" w="med" len="med"/>
+                    </a:lnB>
+                  </a:tcPr>
+                </a:tc>
+                <a:tc>
+                  <a:txBody>
+                    <a:bodyPr/>
+                    <a:lstStyle/>
+                    <a:p>
+                      <a:pPr algn="l" indent="0" marL="0">
+                        <a:buNone/>
+                      </a:pPr>
+                      <a:r>
+                        <a:rPr lang="en-US" sz="1300" dirty="0">
+                          <a:solidFill>
+                            <a:srgbClr val="242424"/>
+                          </a:solidFill>
+                          <a:latin typeface="Red Hat Text" pitchFamily="34" charset="0"/>
+                          <a:ea typeface="Red Hat Text" pitchFamily="34" charset="-122"/>
+                          <a:cs typeface="Red Hat Text" pitchFamily="34" charset="-120"/>
+                        </a:rPr>
+                        <a:t>cosign signature + SBOM + provenance on /hi</a:t>
+                      </a:r>
+                      <a:endParaRPr lang="en-US" sz="1300" dirty="0">
+                        <a:latin typeface="Red Hat Text" charset="0"/>
+                        <a:ea typeface="Red Hat Text" charset="0"/>
+                        <a:cs typeface="Red Hat Text" charset="0"/>
+                      </a:endParaRPr>
+                    </a:p>
+                  </a:txBody>
+                  <a:tcPr marL="91440" marR="91440" marT="45720" marB="45720" anchor="ctr">
+                    <a:lnL w="6350" cap="flat" cmpd="sng" algn="ctr">
+                      <a:solidFill>
+                        <a:srgbClr val="D2D2D2"/>
+                      </a:solidFill>
+                      <a:prstDash val="solid"/>
+                      <a:round/>
+                      <a:headEnd type="none" w="med" len="med"/>
+                      <a:tailEnd type="none" w="med" len="med"/>
+                    </a:lnL>
+                    <a:lnR w="6350" cap="flat" cmpd="sng" algn="ctr">
+                      <a:solidFill>
+                        <a:srgbClr val="D2D2D2"/>
+                      </a:solidFill>
+                      <a:prstDash val="solid"/>
+                      <a:round/>
+                      <a:headEnd type="none" w="med" len="med"/>
+                      <a:tailEnd type="none" w="med" len="med"/>
+                    </a:lnR>
+                    <a:lnT w="6350" cap="flat" cmpd="sng" algn="ctr">
+                      <a:solidFill>
+                        <a:srgbClr val="D2D2D2"/>
+                      </a:solidFill>
+                      <a:prstDash val="solid"/>
+                      <a:round/>
+                      <a:headEnd type="none" w="med" len="med"/>
+                      <a:tailEnd type="none" w="med" len="med"/>
+                    </a:lnT>
+                    <a:lnB w="6350" cap="flat" cmpd="sng" algn="ctr">
+                      <a:solidFill>
+                        <a:srgbClr val="D2D2D2"/>
+                      </a:solidFill>
+                      <a:prstDash val="solid"/>
+                      <a:round/>
+                      <a:headEnd type="none" w="med" len="med"/>
+                      <a:tailEnd type="none" w="med" len="med"/>
+                    </a:lnB>
+                  </a:tcPr>
+                </a:tc>
+              </a:tr>
+              <a:tr h="566928">
+                <a:tc>
+                  <a:txBody>
+                    <a:bodyPr/>
+                    <a:lstStyle/>
+                    <a:p>
+                      <a:pPr algn="l" indent="0" marL="0">
+                        <a:buNone/>
+                      </a:pPr>
+                      <a:r>
+                        <a:rPr lang="en-US" sz="1500" b="1" dirty="0">
+                          <a:solidFill>
+                            <a:srgbClr val="EE0000"/>
+                          </a:solidFill>
+                          <a:latin typeface="Red Hat Mono" pitchFamily="34" charset="0"/>
+                          <a:ea typeface="Red Hat Mono" pitchFamily="34" charset="-122"/>
+                          <a:cs typeface="Red Hat Mono" pitchFamily="34" charset="-120"/>
+                        </a:rPr>
+                        <a:t>Source / file</a:t>
+                      </a:r>
+                      <a:endParaRPr lang="en-US" sz="1500" dirty="0">
+                        <a:latin typeface="Red Hat Mono" charset="0"/>
+                        <a:ea typeface="Red Hat Mono" charset="0"/>
+                        <a:cs typeface="Red Hat Mono" charset="0"/>
+                      </a:endParaRPr>
+                    </a:p>
+                  </a:txBody>
+                  <a:tcPr marL="91440" marR="91440" marT="45720" marB="45720" anchor="ctr">
+                    <a:lnL w="6350" cap="flat" cmpd="sng" algn="ctr">
+                      <a:solidFill>
+                        <a:srgbClr val="D2D2D2"/>
+                      </a:solidFill>
+                      <a:prstDash val="solid"/>
+                      <a:round/>
+                      <a:headEnd type="none" w="med" len="med"/>
+                      <a:tailEnd type="none" w="med" len="med"/>
+                    </a:lnL>
+                    <a:lnR w="6350" cap="flat" cmpd="sng" algn="ctr">
+                      <a:solidFill>
+                        <a:srgbClr val="D2D2D2"/>
+                      </a:solidFill>
+                      <a:prstDash val="solid"/>
+                      <a:round/>
+                      <a:headEnd type="none" w="med" len="med"/>
+                      <a:tailEnd type="none" w="med" len="med"/>
+                    </a:lnR>
+                    <a:lnT w="6350" cap="flat" cmpd="sng" algn="ctr">
+                      <a:solidFill>
+                        <a:srgbClr val="D2D2D2"/>
+                      </a:solidFill>
+                      <a:prstDash val="solid"/>
+                      <a:round/>
+                      <a:headEnd type="none" w="med" len="med"/>
+                      <a:tailEnd type="none" w="med" len="med"/>
+                    </a:lnT>
+                    <a:lnB w="6350" cap="flat" cmpd="sng" algn="ctr">
+                      <a:solidFill>
+                        <a:srgbClr val="D2D2D2"/>
+                      </a:solidFill>
+                      <a:prstDash val="solid"/>
+                      <a:round/>
+                      <a:headEnd type="none" w="med" len="med"/>
+                      <a:tailEnd type="none" w="med" len="med"/>
+                    </a:lnB>
+                  </a:tcPr>
+                </a:tc>
+                <a:tc>
+                  <a:txBody>
+                    <a:bodyPr/>
+                    <a:lstStyle/>
+                    <a:p>
+                      <a:pPr algn="l" indent="0" marL="0">
+                        <a:buNone/>
+                      </a:pPr>
+                      <a:r>
+                        <a:rPr lang="en-US" sz="1400" b="1" dirty="0">
+                          <a:solidFill>
+                            <a:srgbClr val="151515"/>
+                          </a:solidFill>
+                          <a:latin typeface="Red Hat Text" pitchFamily="34" charset="0"/>
+                          <a:ea typeface="Red Hat Text" pitchFamily="34" charset="-122"/>
+                          <a:cs typeface="Red Hat Text" pitchFamily="34" charset="-120"/>
+                        </a:rPr>
+                        <a:t>You</a:t>
+                      </a:r>
+                      <a:endParaRPr lang="en-US" sz="1400" dirty="0">
+                        <a:latin typeface="Red Hat Text" charset="0"/>
+                        <a:ea typeface="Red Hat Text" charset="0"/>
+                        <a:cs typeface="Red Hat Text" charset="0"/>
+                      </a:endParaRPr>
+                    </a:p>
+                  </a:txBody>
+                  <a:tcPr marL="91440" marR="91440" marT="45720" marB="45720" anchor="ctr">
+                    <a:lnL w="6350" cap="flat" cmpd="sng" algn="ctr">
+                      <a:solidFill>
+                        <a:srgbClr val="D2D2D2"/>
+                      </a:solidFill>
+                      <a:prstDash val="solid"/>
+                      <a:round/>
+                      <a:headEnd type="none" w="med" len="med"/>
+                      <a:tailEnd type="none" w="med" len="med"/>
+                    </a:lnL>
+                    <a:lnR w="6350" cap="flat" cmpd="sng" algn="ctr">
+                      <a:solidFill>
+                        <a:srgbClr val="D2D2D2"/>
+                      </a:solidFill>
+                      <a:prstDash val="solid"/>
+                      <a:round/>
+                      <a:headEnd type="none" w="med" len="med"/>
+                      <a:tailEnd type="none" w="med" len="med"/>
+                    </a:lnR>
+                    <a:lnT w="6350" cap="flat" cmpd="sng" algn="ctr">
+                      <a:solidFill>
+                        <a:srgbClr val="D2D2D2"/>
+                      </a:solidFill>
+                      <a:prstDash val="solid"/>
+                      <a:round/>
+                      <a:headEnd type="none" w="med" len="med"/>
+                      <a:tailEnd type="none" w="med" len="med"/>
+                    </a:lnT>
+                    <a:lnB w="6350" cap="flat" cmpd="sng" algn="ctr">
+                      <a:solidFill>
+                        <a:srgbClr val="D2D2D2"/>
+                      </a:solidFill>
+                      <a:prstDash val="solid"/>
+                      <a:round/>
+                      <a:headEnd type="none" w="med" len="med"/>
+                      <a:tailEnd type="none" w="med" len="med"/>
+                    </a:lnB>
+                  </a:tcPr>
+                </a:tc>
+                <a:tc>
+                  <a:txBody>
+                    <a:bodyPr/>
+                    <a:lstStyle/>
+                    <a:p>
+                      <a:pPr algn="l" indent="0" marL="0">
+                        <a:buNone/>
+                      </a:pPr>
+                      <a:r>
+                        <a:rPr lang="en-US" sz="1300" dirty="0">
+                          <a:solidFill>
+                            <a:srgbClr val="242424"/>
+                          </a:solidFill>
+                          <a:latin typeface="Red Hat Text" pitchFamily="34" charset="0"/>
+                          <a:ea typeface="Red Hat Text" pitchFamily="34" charset="-122"/>
+                          <a:cs typeface="Red Hat Text" pitchFamily="34" charset="-120"/>
+                        </a:rPr>
+                        <a:t>Branch protection, signed commits, pin base by digest</a:t>
+                      </a:r>
+                      <a:endParaRPr lang="en-US" sz="1300" dirty="0">
+                        <a:latin typeface="Red Hat Text" charset="0"/>
+                        <a:ea typeface="Red Hat Text" charset="0"/>
+                        <a:cs typeface="Red Hat Text" charset="0"/>
+                      </a:endParaRPr>
+                    </a:p>
+                  </a:txBody>
+                  <a:tcPr marL="91440" marR="91440" marT="45720" marB="45720" anchor="ctr">
+                    <a:lnL w="6350" cap="flat" cmpd="sng" algn="ctr">
+                      <a:solidFill>
+                        <a:srgbClr val="D2D2D2"/>
+                      </a:solidFill>
+                      <a:prstDash val="solid"/>
+                      <a:round/>
+                      <a:headEnd type="none" w="med" len="med"/>
+                      <a:tailEnd type="none" w="med" len="med"/>
+                    </a:lnL>
+                    <a:lnR w="6350" cap="flat" cmpd="sng" algn="ctr">
+                      <a:solidFill>
+                        <a:srgbClr val="D2D2D2"/>
+                      </a:solidFill>
+                      <a:prstDash val="solid"/>
+                      <a:round/>
+                      <a:headEnd type="none" w="med" len="med"/>
+                      <a:tailEnd type="none" w="med" len="med"/>
+                    </a:lnR>
+                    <a:lnT w="6350" cap="flat" cmpd="sng" algn="ctr">
+                      <a:solidFill>
+                        <a:srgbClr val="D2D2D2"/>
+                      </a:solidFill>
+                      <a:prstDash val="solid"/>
+                      <a:round/>
+                      <a:headEnd type="none" w="med" len="med"/>
+                      <a:tailEnd type="none" w="med" len="med"/>
+                    </a:lnT>
+                    <a:lnB w="6350" cap="flat" cmpd="sng" algn="ctr">
+                      <a:solidFill>
+                        <a:srgbClr val="D2D2D2"/>
+                      </a:solidFill>
+                      <a:prstDash val="solid"/>
+                      <a:round/>
+                      <a:headEnd type="none" w="med" len="med"/>
+                      <a:tailEnd type="none" w="med" len="med"/>
+                    </a:lnB>
+                  </a:tcPr>
+                </a:tc>
+              </a:tr>
+              <a:tr h="566928">
+                <a:tc>
+                  <a:txBody>
+                    <a:bodyPr/>
+                    <a:lstStyle/>
+                    <a:p>
+                      <a:pPr algn="l" indent="0" marL="0">
+                        <a:buNone/>
+                      </a:pPr>
+                      <a:r>
+                        <a:rPr lang="en-US" sz="1500" b="1" dirty="0">
+                          <a:solidFill>
+                            <a:srgbClr val="EE0000"/>
+                          </a:solidFill>
+                          <a:latin typeface="Red Hat Mono" pitchFamily="34" charset="0"/>
+                          <a:ea typeface="Red Hat Mono" pitchFamily="34" charset="-122"/>
+                          <a:cs typeface="Red Hat Mono" pitchFamily="34" charset="-120"/>
+                        </a:rPr>
+                        <a:t>Deploy / platform</a:t>
+                      </a:r>
+                      <a:endParaRPr lang="en-US" sz="1500" dirty="0">
+                        <a:latin typeface="Red Hat Mono" charset="0"/>
+                        <a:ea typeface="Red Hat Mono" charset="0"/>
+                        <a:cs typeface="Red Hat Mono" charset="0"/>
+                      </a:endParaRPr>
+                    </a:p>
+                  </a:txBody>
+                  <a:tcPr marL="91440" marR="91440" marT="45720" marB="45720" anchor="ctr">
+                    <a:lnL w="6350" cap="flat" cmpd="sng" algn="ctr">
+                      <a:solidFill>
+                        <a:srgbClr val="D2D2D2"/>
+                      </a:solidFill>
+                      <a:prstDash val="solid"/>
+                      <a:round/>
+                      <a:headEnd type="none" w="med" len="med"/>
+                      <a:tailEnd type="none" w="med" len="med"/>
+                    </a:lnL>
+                    <a:lnR w="6350" cap="flat" cmpd="sng" algn="ctr">
+                      <a:solidFill>
+                        <a:srgbClr val="D2D2D2"/>
+                      </a:solidFill>
+                      <a:prstDash val="solid"/>
+                      <a:round/>
+                      <a:headEnd type="none" w="med" len="med"/>
+                      <a:tailEnd type="none" w="med" len="med"/>
+                    </a:lnR>
+                    <a:lnT w="6350" cap="flat" cmpd="sng" algn="ctr">
+                      <a:solidFill>
+                        <a:srgbClr val="D2D2D2"/>
+                      </a:solidFill>
+                      <a:prstDash val="solid"/>
+                      <a:round/>
+                      <a:headEnd type="none" w="med" len="med"/>
+                      <a:tailEnd type="none" w="med" len="med"/>
+                    </a:lnT>
+                    <a:lnB w="6350" cap="flat" cmpd="sng" algn="ctr">
+                      <a:solidFill>
+                        <a:srgbClr val="D2D2D2"/>
+                      </a:solidFill>
+                      <a:prstDash val="solid"/>
+                      <a:round/>
+                      <a:headEnd type="none" w="med" len="med"/>
+                      <a:tailEnd type="none" w="med" len="med"/>
+                    </a:lnB>
+                  </a:tcPr>
+                </a:tc>
+                <a:tc>
+                  <a:txBody>
+                    <a:bodyPr/>
+                    <a:lstStyle/>
+                    <a:p>
+                      <a:pPr algn="l" indent="0" marL="0">
+                        <a:buNone/>
+                      </a:pPr>
+                      <a:r>
+                        <a:rPr lang="en-US" sz="1400" b="1" dirty="0">
+                          <a:solidFill>
+                            <a:srgbClr val="151515"/>
+                          </a:solidFill>
+                          <a:latin typeface="Red Hat Text" pitchFamily="34" charset="0"/>
+                          <a:ea typeface="Red Hat Text" pitchFamily="34" charset="-122"/>
+                          <a:cs typeface="Red Hat Text" pitchFamily="34" charset="-120"/>
+                        </a:rPr>
+                        <a:t>You</a:t>
+                      </a:r>
+                      <a:endParaRPr lang="en-US" sz="1400" dirty="0">
+                        <a:latin typeface="Red Hat Text" charset="0"/>
+                        <a:ea typeface="Red Hat Text" charset="0"/>
+                        <a:cs typeface="Red Hat Text" charset="0"/>
+                      </a:endParaRPr>
+                    </a:p>
+                  </a:txBody>
+                  <a:tcPr marL="91440" marR="91440" marT="45720" marB="45720" anchor="ctr">
+                    <a:lnL w="6350" cap="flat" cmpd="sng" algn="ctr">
+                      <a:solidFill>
+                        <a:srgbClr val="D2D2D2"/>
+                      </a:solidFill>
+                      <a:prstDash val="solid"/>
+                      <a:round/>
+                      <a:headEnd type="none" w="med" len="med"/>
+                      <a:tailEnd type="none" w="med" len="med"/>
+                    </a:lnL>
+                    <a:lnR w="6350" cap="flat" cmpd="sng" algn="ctr">
+                      <a:solidFill>
+                        <a:srgbClr val="D2D2D2"/>
+                      </a:solidFill>
+                      <a:prstDash val="solid"/>
+                      <a:round/>
+                      <a:headEnd type="none" w="med" len="med"/>
+                      <a:tailEnd type="none" w="med" len="med"/>
+                    </a:lnR>
+                    <a:lnT w="6350" cap="flat" cmpd="sng" algn="ctr">
+                      <a:solidFill>
+                        <a:srgbClr val="D2D2D2"/>
+                      </a:solidFill>
+                      <a:prstDash val="solid"/>
+                      <a:round/>
+                      <a:headEnd type="none" w="med" len="med"/>
+                      <a:tailEnd type="none" w="med" len="med"/>
+                    </a:lnT>
+                    <a:lnB w="6350" cap="flat" cmpd="sng" algn="ctr">
+                      <a:solidFill>
+                        <a:srgbClr val="D2D2D2"/>
+                      </a:solidFill>
+                      <a:prstDash val="solid"/>
+                      <a:round/>
+                      <a:headEnd type="none" w="med" len="med"/>
+                      <a:tailEnd type="none" w="med" len="med"/>
+                    </a:lnB>
+                  </a:tcPr>
+                </a:tc>
+                <a:tc>
+                  <a:txBody>
+                    <a:bodyPr/>
+                    <a:lstStyle/>
+                    <a:p>
+                      <a:pPr algn="l" indent="0" marL="0">
+                        <a:buNone/>
+                      </a:pPr>
+                      <a:r>
+                        <a:rPr lang="en-US" sz="1300" dirty="0">
+                          <a:solidFill>
+                            <a:srgbClr val="242424"/>
+                          </a:solidFill>
+                          <a:latin typeface="Red Hat Text" pitchFamily="34" charset="0"/>
+                          <a:ea typeface="Red Hat Text" pitchFamily="34" charset="-122"/>
+                          <a:cs typeface="Red Hat Text" pitchFamily="34" charset="-120"/>
+                        </a:rPr>
+                        <a:t>OpenShift admission control; host &amp; network hardening</a:t>
+                      </a:r>
+                      <a:endParaRPr lang="en-US" sz="1300" dirty="0">
+                        <a:latin typeface="Red Hat Text" charset="0"/>
+                        <a:ea typeface="Red Hat Text" charset="0"/>
+                        <a:cs typeface="Red Hat Text" charset="0"/>
+                      </a:endParaRPr>
+                    </a:p>
+                  </a:txBody>
+                  <a:tcPr marL="91440" marR="91440" marT="45720" marB="45720" anchor="ctr">
+                    <a:lnL w="6350" cap="flat" cmpd="sng" algn="ctr">
+                      <a:solidFill>
+                        <a:srgbClr val="D2D2D2"/>
+                      </a:solidFill>
+                      <a:prstDash val="solid"/>
+                      <a:round/>
+                      <a:headEnd type="none" w="med" len="med"/>
+                      <a:tailEnd type="none" w="med" len="med"/>
+                    </a:lnL>
+                    <a:lnR w="6350" cap="flat" cmpd="sng" algn="ctr">
+                      <a:solidFill>
+                        <a:srgbClr val="D2D2D2"/>
+                      </a:solidFill>
+                      <a:prstDash val="solid"/>
+                      <a:round/>
+                      <a:headEnd type="none" w="med" len="med"/>
+                      <a:tailEnd type="none" w="med" len="med"/>
+                    </a:lnR>
+                    <a:lnT w="6350" cap="flat" cmpd="sng" algn="ctr">
+                      <a:solidFill>
+                        <a:srgbClr val="D2D2D2"/>
+                      </a:solidFill>
+                      <a:prstDash val="solid"/>
+                      <a:round/>
+                      <a:headEnd type="none" w="med" len="med"/>
+                      <a:tailEnd type="none" w="med" len="med"/>
+                    </a:lnT>
+                    <a:lnB w="6350" cap="flat" cmpd="sng" algn="ctr">
+                      <a:solidFill>
+                        <a:srgbClr val="D2D2D2"/>
+                      </a:solidFill>
+                      <a:prstDash val="solid"/>
+                      <a:round/>
+                      <a:headEnd type="none" w="med" len="med"/>
+                      <a:tailEnd type="none" w="med" len="med"/>
+                    </a:lnB>
+                  </a:tcPr>
+                </a:tc>
+              </a:tr>
+            </a:tbl>
+          </a:graphicData>
+        </a:graphic>
+      </p:graphicFrame>
+      <p:sp>
+        <p:nvSpPr>
+          <p:cNvPr id="7" name="Text 3"/>
+          <p:cNvSpPr/>
+          <p:nvPr/>
+        </p:nvSpPr>
+        <p:spPr>
+          <a:xfrm>
+            <a:off x="566928" y="5943600"/>
+            <a:ext cx="11055096" cy="310896"/>
+          </a:xfrm>
+          <a:prstGeom prst="rect">
+            <a:avLst/>
+          </a:prstGeom>
+          <a:noFill/>
+          <a:ln/>
+        </p:spPr>
+        <p:txBody>
+          <a:bodyPr wrap="square" rtlCol="0" anchor="ctr"/>
+          <a:lstStyle/>
+          <a:p>
+            <a:pPr algn="ctr" indent="0" marL="0">
+              <a:buNone/>
+            </a:pPr>
+            <a:r>
+              <a:rPr lang="en-US" sz="1300" i="1" dirty="0">
+                <a:solidFill>
+                  <a:srgbClr val="5A5A5A"/>
+                </a:solidFill>
+                <a:latin typeface="Red Hat Text" pitchFamily="34" charset="0"/>
+                <a:ea typeface="Red Hat Text" pitchFamily="34" charset="-122"/>
+                <a:cs typeface="Red Hat Text" pitchFamily="34" charset="-120"/>
+              </a:rPr>
+              <a:t>Verify on pull (podman + cosign); enforce for every deploy with an OpenShift admission policy.</a:t>
+            </a:r>
+            <a:endParaRPr lang="en-US" sz="1300" dirty="0"/>
+          </a:p>
+        </p:txBody>
+      </p:sp>
+    </p:spTree>
+  </p:cSld>
+  <p:clrMapOvr>
+    <a:masterClrMapping/>
+  </p:clrMapOvr>
+</p:sld>
+</file>
+
+<file path=ppt/slides/slide37.xml><?xml version="1.0" encoding="utf-8"?>
+<p:sld xmlns:a="http://schemas.openxmlformats.org/drawingml/2006/main" xmlns:r="http://schemas.openxmlformats.org/officeDocument/2006/relationships" xmlns:p="http://schemas.openxmlformats.org/presentationml/2006/main">
+  <p:cSld name="Slide 37">
+    <p:spTree>
+      <p:nvGrpSpPr>
+        <p:cNvPr id="1" name=""/>
+        <p:cNvGrpSpPr/>
+        <p:nvPr/>
+      </p:nvGrpSpPr>
+      <p:grpSpPr>
+        <a:xfrm>
+          <a:off x="0" y="0"/>
+          <a:ext cx="0" cy="0"/>
+          <a:chOff x="0" y="0"/>
+          <a:chExt cx="0" cy="0"/>
+        </a:xfrm>
+      </p:grpSpPr>
+      <p:sp>
+        <p:nvSpPr>
+          <p:cNvPr id="2" name="Text 0"/>
+          <p:cNvSpPr/>
+          <p:nvPr/>
+        </p:nvSpPr>
+        <p:spPr>
+          <a:xfrm>
+            <a:off x="566928" y="6364224"/>
+            <a:ext cx="914400" cy="274320"/>
+          </a:xfrm>
+          <a:prstGeom prst="rect">
+            <a:avLst/>
+          </a:prstGeom>
+          <a:noFill/>
+          <a:ln/>
+        </p:spPr>
+        <p:txBody>
+          <a:bodyPr wrap="square" rtlCol="0" anchor="ctr"/>
+          <a:lstStyle/>
+          <a:p>
+            <a:pPr algn="l" indent="0" marL="0">
+              <a:buNone/>
+            </a:pPr>
+            <a:r>
+              <a:rPr lang="en-US" sz="1000" dirty="0">
+                <a:solidFill>
+                  <a:srgbClr val="8A8A8A"/>
+                </a:solidFill>
+                <a:latin typeface="Red Hat Text" pitchFamily="34" charset="0"/>
+                <a:ea typeface="Red Hat Text" pitchFamily="34" charset="-122"/>
+                <a:cs typeface="Red Hat Text" pitchFamily="34" charset="-120"/>
+              </a:rPr>
+              <a:t>37</a:t>
             </a:r>
             <a:endParaRPr lang="en-US" sz="1000" dirty="0"/>
           </a:p>

</xml_diff>

<commit_message>
ch.18: add generic supply-chain stage-setter (Fig 18.1), renumber figures, drop attribution from 18.1; deck r01.4
</commit_message>
<xml_diff>
--- a/presentations/hummingbird-overview.pptx
+++ b/presentations/hummingbird-overview.pptx
@@ -42,9 +42,10 @@
     <p:sldId id="290" r:id="rId36"/>
     <p:sldId id="291" r:id="rId37"/>
     <p:sldId id="292" r:id="rId38"/>
+    <p:sldId id="293" r:id="rId39"/>
   </p:sldIdLst>
   <p:notesMasterIdLst>
-    <p:notesMasterId r:id="rId39"/>
+    <p:notesMasterId r:id="rId40"/>
   </p:notesMasterIdLst>
   <p:sldSz cx="12192000" cy="6858000"/>
   <p:notesSz cx="6858000" cy="12192000"/>
@@ -2914,7 +2915,7 @@
           <a:p>
             <a:r>
               <a:rPr lang="en-US" dirty="0"/>
-              <a:t>The canonical container supply-chain threat model, reframed for our stack: Buildah/Konflux instead of Docker, the signed registry.access.redhat.com/hi path, OpenShift at deploy. Top row: the classic vectors. Bottom row: the Hummingbird answer. The story to tell — a hardened base turns the three hardest vectors (vulnerable base, vulnerable dependencies, build tampering) from 'trust us' into signed evidence you verify yourself, and the minimalism means there's simply less inside to be vulnerable. Be candid about the left edge: tampered source and a tampered Containerfile are the operator's job — branch protection, signed commits, pin the base by digest. Hummingbird gives you a trustworthy FROM; it can't stop an insecure Containerfile on top of it.</a:t>
+              <a:t>Set the stage with the generic picture first — this is the standard container supply-chain threat model, terminology-neutral, before any Hummingbird framing. A container image is assembled from a chain of inputs — source, the build file, a base image, packages — then built, stored, and deployed, and every hand-off is a place to interfere: tamper with source or the Containerfile, a vulnerable base or dependency, build-time tampering or a compromised build host, a swapped image in the registry, an intercepted pull, or a malicious deployment definition. Hold this picture; the next slide overlays the answer.</a:t>
             </a:r>
             <a:endParaRPr lang="en-US" dirty="0"/>
           </a:p>
@@ -3002,7 +3003,7 @@
           <a:p>
             <a:r>
               <a:rPr lang="en-US" dirty="0"/>
-              <a:t>The pipeline view was build-and-delivery; this is runtime — defense in depth. The hardened image shrinks the cluster of vectors aimed at the image and the app: a swapped image fails cosign verify; distroless removes the foot-guns (no shell, no package manager, non-root UID 65532); fewer packages mean fewer exploitable paths and very little for an intruder to use if they do land inside. What it does NOT fix sits outside the container — misconfigured host, insecure networking, container escape — and those are platform hardening: rootless Podman, SELinux, seccomp, OpenShift SCCs, network policy. The hardened image is one strong layer, not the whole onion.</a:t>
+              <a:t>Same chain, reframed for our stack: Buildah/Konflux instead of Docker, the signed registry.access.redhat.com/hi path, OpenShift at deploy. Top row: the classic vectors. Bottom row: the Hummingbird answer. The story to tell — a hardened base turns the three hardest vectors (vulnerable base, vulnerable dependencies, build tampering) from 'trust us' into signed evidence you verify yourself, and the minimalism means there's simply less inside to be vulnerable. Be candid about the left edge: tampered source and a tampered Containerfile are the operator's job — branch protection, signed commits, pin the base by digest. Hummingbird gives you a trustworthy FROM; it can't stop an insecure Containerfile on top of it.</a:t>
             </a:r>
             <a:endParaRPr lang="en-US" dirty="0"/>
           </a:p>
@@ -3090,7 +3091,7 @@
           <a:p>
             <a:r>
               <a:rPr lang="en-US" dirty="0"/>
-              <a:t>The honest summary, and a good place to end an admin talk. Hummingbird owns the image — vulnerable base, vulnerable dependencies, build integrity, image authenticity — the part that's genuinely hard to do yourself and that you get for free. You own the edges — source and Containerfile integrity, platform hardening, and the admission gate that enforces verification for every deploy. The practical close: verify on pull with podman + cosign, and enforce it cluster-wide with an OpenShift admission policy so no one can route around the check — that's what closes the malicious-deployment-definition vector. A near-zero-CVE distroless base is the strongest single move on the supply chain precisely because it collapses the vectors that are hardest to defend one at a time.</a:t>
+              <a:t>The pipeline view was build-and-delivery; this is runtime — defense in depth. The hardened image shrinks the cluster of vectors aimed at the image and the app: a swapped image fails cosign verify; distroless removes the foot-guns (no shell, no package manager, non-root UID 65532); fewer packages mean fewer exploitable paths and very little for an intruder to use if they do land inside. What it does NOT fix sits outside the container — misconfigured host, insecure networking, container escape — and those are platform hardening: rootless Podman, SELinux, seccomp, OpenShift SCCs, network policy. The hardened image is one strong layer, not the whole onion.</a:t>
             </a:r>
             <a:endParaRPr lang="en-US" dirty="0"/>
           </a:p>
@@ -3178,7 +3179,7 @@
           <a:p>
             <a:r>
               <a:rPr lang="en-US" dirty="0"/>
-              <a:t>Recap the arc and point to where to go deeper. One idea drives everything — rebuild instead of patch — and it gives you distroless, near-zero-CVE images on a trust chain you may already rely on. The entire workflow fits on a laptop with Podman. The strongest closing note for an admin audience: near-zero CVE isn't something to take on faith — it's one Grype command away from being your own measurement, and the work that remains is the tractable part, keeping your own dependencies current. And it's not all-or-nothing: use Hummingbird where minimalism wins and UBI where breadth does. Everything in this deck — chapters, runnable examples, and the demos — lives in the tutorial repo and site.</a:t>
+              <a:t>The honest summary, and a good place to end an admin talk. Hummingbird owns the image — vulnerable base, vulnerable dependencies, build integrity, image authenticity — the part that's genuinely hard to do yourself and that you get for free. You own the edges — source and Containerfile integrity, platform hardening, and the admission gate that enforces verification for every deploy. The practical close: verify on pull with podman + cosign, and enforce it cluster-wide with an OpenShift admission policy so no one can route around the check — that's what closes the malicious-deployment-definition vector. A near-zero-CVE distroless base is the strongest single move on the supply chain precisely because it collapses the vectors that are hardest to defend one at a time.</a:t>
             </a:r>
             <a:endParaRPr lang="en-US" dirty="0"/>
           </a:p>
@@ -3202,6 +3203,94 @@
             <a:fld id="{F7021451-1387-4CA6-816F-3879F97B5CBC}" type="slidenum">
               <a:rPr lang="en-US"/>
               <a:t>37</a:t>
+            </a:fld>
+            <a:endParaRPr lang="en-US"/>
+          </a:p>
+        </p:txBody>
+      </p:sp>
+    </p:spTree>
+    <p:extLst>
+      <p:ext uri="{BB962C8B-B14F-4D97-AF65-F5344CB8AC3E}">
+        <p14:creationId xmlns:p14="http://schemas.microsoft.com/office/powerpoint/2010/main" val="1024086991"/>
+      </p:ext>
+    </p:extLst>
+  </p:cSld>
+  <p:clrMapOvr>
+    <a:masterClrMapping/>
+  </p:clrMapOvr>
+</p:notes>
+</file>
+
+<file path=ppt/notesSlides/notesSlide38.xml><?xml version="1.0" encoding="utf-8"?>
+<p:notes xmlns:a="http://schemas.openxmlformats.org/drawingml/2006/main" xmlns:r="http://schemas.openxmlformats.org/officeDocument/2006/relationships" xmlns:p="http://schemas.openxmlformats.org/presentationml/2006/main">
+  <p:cSld>
+    <p:spTree>
+      <p:nvGrpSpPr>
+        <p:cNvPr id="1" name=""/>
+        <p:cNvGrpSpPr/>
+        <p:nvPr/>
+      </p:nvGrpSpPr>
+      <p:grpSpPr>
+        <a:xfrm>
+          <a:off x="0" y="0"/>
+          <a:ext cx="0" cy="0"/>
+          <a:chOff x="0" y="0"/>
+          <a:chExt cx="0" cy="0"/>
+        </a:xfrm>
+      </p:grpSpPr>
+      <p:sp>
+        <p:nvSpPr>
+          <p:cNvPr id="2" name="Slide Image Placeholder 1"/>
+          <p:cNvSpPr>
+            <a:spLocks noGrp="1" noRot="1" noChangeAspect="1"/>
+          </p:cNvSpPr>
+          <p:nvPr>
+            <p:ph type="sldImg"/>
+          </p:nvPr>
+        </p:nvSpPr>
+        <p:spPr/>
+      </p:sp>
+      <p:sp>
+        <p:nvSpPr>
+          <p:cNvPr id="3" name="Notes Placeholder 2"/>
+          <p:cNvSpPr>
+            <a:spLocks noGrp="1"/>
+          </p:cNvSpPr>
+          <p:nvPr>
+            <p:ph type="body" idx="1"/>
+          </p:nvPr>
+        </p:nvSpPr>
+        <p:spPr/>
+        <p:txBody>
+          <a:bodyPr/>
+          <a:lstStyle/>
+          <a:p>
+            <a:r>
+              <a:rPr lang="en-US" dirty="0"/>
+              <a:t>Recap the arc and point to where to go deeper. One idea drives everything — rebuild instead of patch — and it gives you distroless, near-zero-CVE images on a trust chain you may already rely on. The entire workflow fits on a laptop with Podman. The strongest closing note for an admin audience: near-zero CVE isn't something to take on faith — it's one Grype command away from being your own measurement, and the work that remains is the tractable part, keeping your own dependencies current. And it's not all-or-nothing: use Hummingbird where minimalism wins and UBI where breadth does. Everything in this deck — chapters, runnable examples, and the demos — lives in the tutorial repo and site.</a:t>
+            </a:r>
+            <a:endParaRPr lang="en-US" dirty="0"/>
+          </a:p>
+        </p:txBody>
+      </p:sp>
+      <p:sp>
+        <p:nvSpPr>
+          <p:cNvPr id="4" name="Slide Number Placeholder 3"/>
+          <p:cNvSpPr>
+            <a:spLocks noGrp="1"/>
+          </p:cNvSpPr>
+          <p:nvPr>
+            <p:ph type="sldNum" sz="quarter" idx="10"/>
+          </p:nvPr>
+        </p:nvSpPr>
+        <p:spPr/>
+        <p:txBody>
+          <a:bodyPr/>
+          <a:lstStyle/>
+          <a:p>
+            <a:fld id="{F7021451-1387-4CA6-816F-3879F97B5CBC}" type="slidenum">
+              <a:rPr lang="en-US"/>
+              <a:t>38</a:t>
             </a:fld>
             <a:endParaRPr lang="en-US"/>
           </a:p>
@@ -4270,7 +4359,7 @@
                 <a:ea typeface="Red Hat Mono" pitchFamily="34" charset="-122"/>
                 <a:cs typeface="Red Hat Mono" pitchFamily="34" charset="-120"/>
               </a:rPr>
-              <a:t>r01.3</a:t>
+              <a:t>r01.4</a:t>
             </a:r>
             <a:endParaRPr lang="en-US" sz="1100" dirty="0"/>
           </a:p>
@@ -13855,7 +13944,7 @@
                 <a:ea typeface="Overpass" pitchFamily="34" charset="-122"/>
                 <a:cs typeface="Overpass" pitchFamily="34" charset="-120"/>
               </a:rPr>
-              <a:t>SUPPLY CHAIN · ATTACK VECTORS</a:t>
+              <a:t>SUPPLY CHAIN · THE PROBLEM</a:t>
             </a:r>
             <a:endParaRPr lang="en-US" sz="1200" dirty="0"/>
           </a:p>
@@ -13894,7 +13983,7 @@
                 <a:ea typeface="Overpass" pitchFamily="34" charset="-122"/>
                 <a:cs typeface="Overpass" pitchFamily="34" charset="-120"/>
               </a:rPr>
-              <a:t>The chain, and where it's attacked</a:t>
+              <a:t>Where the supply chain gets attacked</a:t>
             </a:r>
             <a:endParaRPr lang="en-US" sz="3000" dirty="0"/>
           </a:p>
@@ -13902,7 +13991,7 @@
       </p:sp>
       <p:pic>
         <p:nvPicPr>
-          <p:cNvPr id="6" name="Image 1" descr="./png/18-supply-chain-security-attack-vectors.png">    </p:cNvPr>
+          <p:cNvPr id="6" name="Image 1" descr="./png/18-supply-chain-security-the-chain.png">    </p:cNvPr>
           <p:cNvPicPr>
             <a:picLocks noChangeAspect="1"/>
           </p:cNvPicPr>
@@ -13956,7 +14045,7 @@
                 <a:ea typeface="Red Hat Text" pitchFamily="34" charset="-122"/>
                 <a:cs typeface="Red Hat Text" pitchFamily="34" charset="-120"/>
               </a:rPr>
-              <a:t>Figure 18.1 — Attack vectors (after Liz Rice, Container Security 2e, Fig 7-1) and the Hummingbird answer at each stage.</a:t>
+              <a:t>Figure 18.1 — The container supply chain, and where it gets attacked.</a:t>
             </a:r>
             <a:endParaRPr lang="en-US" sz="1300" dirty="0"/>
           </a:p>
@@ -14083,7 +14172,7 @@
                 <a:ea typeface="Overpass" pitchFamily="34" charset="-122"/>
                 <a:cs typeface="Overpass" pitchFamily="34" charset="-120"/>
               </a:rPr>
-              <a:t>SUPPLY CHAIN · RUNTIME SURFACE</a:t>
+              <a:t>SUPPLY CHAIN · THE ANSWER</a:t>
             </a:r>
             <a:endParaRPr lang="en-US" sz="1200" dirty="0"/>
           </a:p>
@@ -14122,7 +14211,7 @@
                 <a:ea typeface="Overpass" pitchFamily="34" charset="-122"/>
                 <a:cs typeface="Overpass" pitchFamily="34" charset="-120"/>
               </a:rPr>
-              <a:t>Defense in depth — and where the image helps</a:t>
+              <a:t>The same chain, with the Hummingbird answer</a:t>
             </a:r>
             <a:endParaRPr lang="en-US" sz="3000" dirty="0"/>
           </a:p>
@@ -14130,7 +14219,7 @@
       </p:sp>
       <p:pic>
         <p:nvPicPr>
-          <p:cNvPr id="6" name="Image 1" descr="./png/18-supply-chain-security-layers.png">    </p:cNvPr>
+          <p:cNvPr id="6" name="Image 1" descr="./png/18-supply-chain-security-attack-vectors.png">    </p:cNvPr>
           <p:cNvPicPr>
             <a:picLocks noChangeAspect="1"/>
           </p:cNvPicPr>
@@ -14184,7 +14273,7 @@
                 <a:ea typeface="Red Hat Text" pitchFamily="34" charset="-122"/>
                 <a:cs typeface="Red Hat Text" pitchFamily="34" charset="-120"/>
               </a:rPr>
-              <a:t>Figure 18.2 — The layered runtime attack surface; the hardened image shrinks the image-and-app cluster, not the platform.</a:t>
+              <a:t>Figure 18.2 — Attack vectors and the Hummingbird answer at each stage, on Podman/Konflux/OpenShift.</a:t>
             </a:r>
             <a:endParaRPr lang="en-US" sz="1300" dirty="0"/>
           </a:p>
@@ -14311,7 +14400,7 @@
                 <a:ea typeface="Overpass" pitchFamily="34" charset="-122"/>
                 <a:cs typeface="Overpass" pitchFamily="34" charset="-120"/>
               </a:rPr>
-              <a:t>SUPPLY CHAIN · DIVISION OF LABOUR</a:t>
+              <a:t>SUPPLY CHAIN · RUNTIME SURFACE</a:t>
             </a:r>
             <a:endParaRPr lang="en-US" sz="1200" dirty="0"/>
           </a:p>
@@ -14350,6 +14439,234 @@
                 <a:ea typeface="Overpass" pitchFamily="34" charset="-122"/>
                 <a:cs typeface="Overpass" pitchFamily="34" charset="-120"/>
               </a:rPr>
+              <a:t>Defense in depth — and where the image helps</a:t>
+            </a:r>
+            <a:endParaRPr lang="en-US" sz="3000" dirty="0"/>
+          </a:p>
+        </p:txBody>
+      </p:sp>
+      <p:pic>
+        <p:nvPicPr>
+          <p:cNvPr id="6" name="Image 1" descr="./png/18-supply-chain-security-layers.png">    </p:cNvPr>
+          <p:cNvPicPr>
+            <a:picLocks noChangeAspect="1"/>
+          </p:cNvPicPr>
+          <p:nvPr/>
+        </p:nvPicPr>
+        <p:blipFill>
+          <a:blip r:embed="rId2"/>
+          <a:srcRect l="0" r="0" t="0" b="0"/>
+          <a:stretch/>
+        </p:blipFill>
+        <p:spPr>
+          <a:xfrm>
+            <a:off x="1645920" y="1600200"/>
+            <a:ext cx="8906256" cy="4343400"/>
+          </a:xfrm>
+          <a:prstGeom prst="rect">
+            <a:avLst/>
+          </a:prstGeom>
+        </p:spPr>
+      </p:pic>
+      <p:sp>
+        <p:nvSpPr>
+          <p:cNvPr id="7" name="Text 3"/>
+          <p:cNvSpPr/>
+          <p:nvPr/>
+        </p:nvSpPr>
+        <p:spPr>
+          <a:xfrm>
+            <a:off x="566928" y="5943600"/>
+            <a:ext cx="11055096" cy="310896"/>
+          </a:xfrm>
+          <a:prstGeom prst="rect">
+            <a:avLst/>
+          </a:prstGeom>
+          <a:noFill/>
+          <a:ln/>
+        </p:spPr>
+        <p:txBody>
+          <a:bodyPr wrap="square" rtlCol="0" anchor="ctr"/>
+          <a:lstStyle/>
+          <a:p>
+            <a:pPr algn="ctr" indent="0" marL="0">
+              <a:buNone/>
+            </a:pPr>
+            <a:r>
+              <a:rPr lang="en-US" sz="1300" i="1" dirty="0">
+                <a:solidFill>
+                  <a:srgbClr val="5A5A5A"/>
+                </a:solidFill>
+                <a:latin typeface="Red Hat Text" pitchFamily="34" charset="0"/>
+                <a:ea typeface="Red Hat Text" pitchFamily="34" charset="-122"/>
+                <a:cs typeface="Red Hat Text" pitchFamily="34" charset="-120"/>
+              </a:rPr>
+              <a:t>Figure 18.3 — The layered runtime attack surface; the hardened image shrinks the image-and-app cluster, not the platform.</a:t>
+            </a:r>
+            <a:endParaRPr lang="en-US" sz="1300" dirty="0"/>
+          </a:p>
+        </p:txBody>
+      </p:sp>
+    </p:spTree>
+  </p:cSld>
+  <p:clrMapOvr>
+    <a:masterClrMapping/>
+  </p:clrMapOvr>
+</p:sld>
+</file>
+
+<file path=ppt/slides/slide37.xml><?xml version="1.0" encoding="utf-8"?>
+<p:sld xmlns:a="http://schemas.openxmlformats.org/drawingml/2006/main" xmlns:r="http://schemas.openxmlformats.org/officeDocument/2006/relationships" xmlns:p="http://schemas.openxmlformats.org/presentationml/2006/main">
+  <p:cSld name="Slide 37">
+    <p:spTree>
+      <p:nvGrpSpPr>
+        <p:cNvPr id="1" name=""/>
+        <p:cNvGrpSpPr/>
+        <p:nvPr/>
+      </p:nvGrpSpPr>
+      <p:grpSpPr>
+        <a:xfrm>
+          <a:off x="0" y="0"/>
+          <a:ext cx="0" cy="0"/>
+          <a:chOff x="0" y="0"/>
+          <a:chExt cx="0" cy="0"/>
+        </a:xfrm>
+      </p:grpSpPr>
+      <p:sp>
+        <p:nvSpPr>
+          <p:cNvPr id="2" name="Text 0"/>
+          <p:cNvSpPr/>
+          <p:nvPr/>
+        </p:nvSpPr>
+        <p:spPr>
+          <a:xfrm>
+            <a:off x="566928" y="6364224"/>
+            <a:ext cx="914400" cy="274320"/>
+          </a:xfrm>
+          <a:prstGeom prst="rect">
+            <a:avLst/>
+          </a:prstGeom>
+          <a:noFill/>
+          <a:ln/>
+        </p:spPr>
+        <p:txBody>
+          <a:bodyPr wrap="square" rtlCol="0" anchor="ctr"/>
+          <a:lstStyle/>
+          <a:p>
+            <a:pPr algn="l" indent="0" marL="0">
+              <a:buNone/>
+            </a:pPr>
+            <a:r>
+              <a:rPr lang="en-US" sz="1000" dirty="0">
+                <a:solidFill>
+                  <a:srgbClr val="8A8A8A"/>
+                </a:solidFill>
+                <a:latin typeface="Red Hat Text" pitchFamily="34" charset="0"/>
+                <a:ea typeface="Red Hat Text" pitchFamily="34" charset="-122"/>
+                <a:cs typeface="Red Hat Text" pitchFamily="34" charset="-120"/>
+              </a:rPr>
+              <a:t>37</a:t>
+            </a:r>
+            <a:endParaRPr lang="en-US" sz="1000" dirty="0"/>
+          </a:p>
+        </p:txBody>
+      </p:sp>
+      <p:pic>
+        <p:nvPicPr>
+          <p:cNvPr id="3" name="Image 0" descr="./assets/logo-candidate-2.png">    </p:cNvPr>
+          <p:cNvPicPr>
+            <a:picLocks noChangeAspect="1"/>
+          </p:cNvPicPr>
+          <p:nvPr/>
+        </p:nvPicPr>
+        <p:blipFill>
+          <a:blip r:embed="rId1"/>
+          <a:stretch>
+            <a:fillRect/>
+          </a:stretch>
+        </p:blipFill>
+        <p:spPr>
+          <a:xfrm>
+            <a:off x="10561320" y="6355080"/>
+            <a:ext cx="1033272" cy="246888"/>
+          </a:xfrm>
+          <a:prstGeom prst="rect">
+            <a:avLst/>
+          </a:prstGeom>
+        </p:spPr>
+      </p:pic>
+      <p:sp>
+        <p:nvSpPr>
+          <p:cNvPr id="4" name="Text 1"/>
+          <p:cNvSpPr/>
+          <p:nvPr/>
+        </p:nvSpPr>
+        <p:spPr>
+          <a:xfrm>
+            <a:off x="566928" y="384048"/>
+            <a:ext cx="11055096" cy="292608"/>
+          </a:xfrm>
+          <a:prstGeom prst="rect">
+            <a:avLst/>
+          </a:prstGeom>
+          <a:noFill/>
+          <a:ln/>
+        </p:spPr>
+        <p:txBody>
+          <a:bodyPr wrap="square" rtlCol="0" anchor="ctr"/>
+          <a:lstStyle/>
+          <a:p>
+            <a:pPr algn="l" indent="0" marL="0">
+              <a:buNone/>
+            </a:pPr>
+            <a:r>
+              <a:rPr lang="en-US" sz="1200" b="1" spc="400" kern="0" dirty="0">
+                <a:solidFill>
+                  <a:srgbClr val="EE0000"/>
+                </a:solidFill>
+                <a:latin typeface="Overpass" pitchFamily="34" charset="0"/>
+                <a:ea typeface="Overpass" pitchFamily="34" charset="-122"/>
+                <a:cs typeface="Overpass" pitchFamily="34" charset="-120"/>
+              </a:rPr>
+              <a:t>SUPPLY CHAIN · DIVISION OF LABOUR</a:t>
+            </a:r>
+            <a:endParaRPr lang="en-US" sz="1200" dirty="0"/>
+          </a:p>
+        </p:txBody>
+      </p:sp>
+      <p:sp>
+        <p:nvSpPr>
+          <p:cNvPr id="5" name="Text 2"/>
+          <p:cNvSpPr/>
+          <p:nvPr/>
+        </p:nvSpPr>
+        <p:spPr>
+          <a:xfrm>
+            <a:off x="566928" y="676656"/>
+            <a:ext cx="11055096" cy="1005840"/>
+          </a:xfrm>
+          <a:prstGeom prst="rect">
+            <a:avLst/>
+          </a:prstGeom>
+          <a:noFill/>
+          <a:ln/>
+        </p:spPr>
+        <p:txBody>
+          <a:bodyPr wrap="square" rtlCol="0" anchor="t"/>
+          <a:lstStyle/>
+          <a:p>
+            <a:pPr algn="l" indent="0" marL="0">
+              <a:buNone/>
+            </a:pPr>
+            <a:r>
+              <a:rPr lang="en-US" sz="3000" b="1" dirty="0">
+                <a:solidFill>
+                  <a:srgbClr val="151515"/>
+                </a:solidFill>
+                <a:latin typeface="Overpass" pitchFamily="34" charset="0"/>
+                <a:ea typeface="Overpass" pitchFamily="34" charset="-122"/>
+                <a:cs typeface="Overpass" pitchFamily="34" charset="-120"/>
+              </a:rPr>
               <a:t>What Hummingbird closes — and what's still yours</a:t>
             </a:r>
             <a:endParaRPr lang="en-US" sz="3000" dirty="0"/>
@@ -14358,7 +14675,7 @@
       </p:sp>
       <p:graphicFrame>
         <p:nvGraphicFramePr>
-          <p:cNvPr id="37" name="Table 0"/>
+          <p:cNvPr id="38" name="Table 0"/>
           <p:cNvGraphicFramePr>
             <a:graphicFrameLocks noGrp="1"/>
           </p:cNvGraphicFramePr>
@@ -15616,9 +15933,9 @@
 </p:sld>
 </file>
 
-<file path=ppt/slides/slide37.xml><?xml version="1.0" encoding="utf-8"?>
+<file path=ppt/slides/slide38.xml><?xml version="1.0" encoding="utf-8"?>
 <p:sld xmlns:a="http://schemas.openxmlformats.org/drawingml/2006/main" xmlns:r="http://schemas.openxmlformats.org/officeDocument/2006/relationships" xmlns:p="http://schemas.openxmlformats.org/presentationml/2006/main">
-  <p:cSld name="Slide 37">
+  <p:cSld name="Slide 38">
     <p:spTree>
       <p:nvGrpSpPr>
         <p:cNvPr id="1" name=""/>
@@ -15666,7 +15983,7 @@
                 <a:ea typeface="Red Hat Text" pitchFamily="34" charset="-122"/>
                 <a:cs typeface="Red Hat Text" pitchFamily="34" charset="-120"/>
               </a:rPr>
-              <a:t>37</a:t>
+              <a:t>38</a:t>
             </a:r>
             <a:endParaRPr lang="en-US" sz="1000" dirty="0"/>
           </a:p>

</xml_diff>

<commit_message>
Deck r01.5: drop tutorial-companion framing and hedging words
</commit_message>
<xml_diff>
--- a/presentations/hummingbird-overview.pptx
+++ b/presentations/hummingbird-overview.pptx
@@ -891,7 +891,7 @@
           <a:p>
             <a:r>
               <a:rPr lang="en-US" dirty="0"/>
-              <a:t>Most platforms end up with both, so compare them honestly. UBI is the flexible, broad, predictable RHEL base with a 10-year life cycle. Hummingbird is the minimal, rolling, purpose-built hardened base. Both are free; the GA difference to state correctly is that Hardened Images are free to use on any Linux distro, Kubernetes, or container engine — vendor-neutral — with optional LTS images planned via subscription, rather than support being tied to a RHEL/OpenShift subscription. The decision rule repeats: UBI when you need RHEL breadth or dnf at runtime; Hummingbird when you want the smallest, hardest-to-attack runtime — usually the deploy stage. The gotchas section gives concrete failure modes for when the minimal runtime is the wrong tool.</a:t>
+              <a:t>Most platforms end up with both, so compare them on the merits. UBI is the flexible, broad, predictable RHEL base with a 10-year life cycle. Hummingbird is the minimal, rolling, purpose-built hardened base. Both are free; the GA difference to state correctly is that Hardened Images are free to use on any Linux distro, Kubernetes, or container engine — vendor-neutral — with optional LTS images planned via subscription, rather than support being tied to a RHEL/OpenShift subscription. The decision rule repeats: UBI when you need RHEL breadth or dnf at runtime; Hummingbird when you want the smallest, hardest-to-attack runtime — usually the deploy stage. The gotchas section gives concrete failure modes for when the minimal runtime is the wrong tool.</a:t>
             </a:r>
             <a:endParaRPr lang="en-US" dirty="0"/>
           </a:p>
@@ -1067,7 +1067,7 @@
           <a:p>
             <a:r>
               <a:rPr lang="en-US" dirty="0"/>
-              <a:t>Now the hands-on arc, kept brief — one stop per tutorial section, led by its diagram. Prerequisites and the registry model; pulling and inspecting; the debug-sidecar pattern and the broader debugging strategy; multi-stage builds; SBOMs and signing; CVE scanning; multi-service compose; the two layer-efficiency features; trusted libraries and provenance; and the distroless gotchas. Each of these has a full chapter and a runnable example in the tutorial.</a:t>
+              <a:t>Now the hands-on arc, kept brief — one stop per topic, led by its diagram. Prerequisites and the registry model; pulling and inspecting; the debug-sidecar pattern and the broader debugging strategy; multi-stage builds; SBOMs and signing; CVE scanning; multi-service compose; the two layer-efficiency features; trusted libraries and provenance; and the distroless gotchas. Each has a runnable example.</a:t>
             </a:r>
             <a:endParaRPr lang="en-US" dirty="0"/>
           </a:p>
@@ -1155,7 +1155,7 @@
           <a:p>
             <a:r>
               <a:rPr lang="en-US" dirty="0"/>
-              <a:t>The setup chapter pins the environment: Podman and Skopeo for images, Syft for SBOMs, Grype for scanning, Cosign for signatures — all sharing one registry-auth file. It also establishes the registry shortcuts the tutorial uses: HB_REGISTRY=quay.io/hummingbird is the Project Hummingbird community org on Quay, RH_REGISTRY=registry.access.redhat.com is UBI and the toolbox, and the signed Red Hat path is used for verification. Note for GA: the Red Hat Hardened Images catalog now lives at images.redhat.com — browse there for the canonical image names and pull paths, and confirm them before a talk. One Fedora-44 note from the field: install Cosign from the upstream RPM, not dnf, which is currently broken there.</a:t>
+              <a:t>Setup pins the environment: Podman and Skopeo for images, Syft for SBOMs, Grype for scanning, Cosign for signatures — all sharing one registry-auth file. It also establishes the registry shortcuts used here: HB_REGISTRY=quay.io/hummingbird is the Project Hummingbird community org on Quay, RH_REGISTRY=registry.access.redhat.com is UBI and the toolbox, and the signed Red Hat path is used for verification. Note for GA: the Red Hat Hardened Images catalog now lives at images.redhat.com — browse there for the canonical image names and pull paths, and confirm them before a talk. One Fedora-44 note from the field: install Cosign from the upstream RPM, not dnf, which is currently broken there.</a:t>
             </a:r>
             <a:endParaRPr lang="en-US" dirty="0"/>
           </a:p>
@@ -1243,7 +1243,7 @@
           <a:p>
             <a:r>
               <a:rPr lang="en-US" dirty="0"/>
-              <a:t>The first hands-on chapter: pull an image, then read its manifest two ways — locally with podman inspect, remotely with skopeo inspect (no pull needed) — looking at the layer count and the provenance labels. Then the moment that surprises everyone from general-purpose bases: podman exec into a shell fails, because there is no shell. The image isn't broken — the application is the entrypoint. That single behavior reframes how you operate these images, and it sets up the debugging section.</a:t>
+              <a:t>The first hands-on topic: pull an image, then read its manifest two ways — locally with podman inspect, remotely with skopeo inspect (no pull needed) — looking at the layer count and the provenance labels. Then the moment that surprises everyone from general-purpose bases: podman exec into a shell fails, because there is no shell. The image isn't broken — the application is the entrypoint. That single behavior reframes how you operate these images, and it sets up the debugging section.</a:t>
             </a:r>
             <a:endParaRPr lang="en-US" dirty="0"/>
           </a:p>
@@ -1507,7 +1507,7 @@
           <a:p>
             <a:r>
               <a:rPr lang="en-US" dirty="0"/>
-              <a:t>This is the part to get right before touching a terminal. We'll cover what the catalog is, the one idea that drives the whole design — rebuild instead of patch — what 'near-zero CVE' honestly means, where Hummingbird sits next to UBI, what's deliberately left out of an image, the image variants, what 'hardened' means concretely, and the three named concepts behind the trust chain. Once this lands, the commands later read as obvious rather than magic.</a:t>
+              <a:t>This is the part to get right before touching a terminal. We'll cover what the catalog is, the one idea that drives the whole design — rebuild instead of patch — what 'near-zero CVE' really means, where Hummingbird sits next to UBI, what's deliberately left out of an image, the image variants, what 'hardened' means concretely, and the three named concepts behind the trust chain. Once this lands, the commands later read as obvious rather than magic.</a:t>
             </a:r>
             <a:endParaRPr lang="en-US" dirty="0"/>
           </a:p>
@@ -1771,7 +1771,7 @@
           <a:p>
             <a:r>
               <a:rPr lang="en-US" dirty="0"/>
-              <a:t>This is where the claim becomes a number you can reproduce. Grype turns the small package list into a CVE count. Two honest caveats up front: a match is a reported CVE against a present package version, not proof it's reachable; and the database updates daily, so comparisons are only fair against the same DB. The side-by-side — hardened versus general-purpose — is the payoff, and scanning your own derived image reframes the job: the base is clean, so all that's left is keeping your direct dependencies patched. --fail-on high is the CI gate.</a:t>
+              <a:t>This is where the claim becomes a number you can reproduce. Grype turns the small package list into a CVE count. Two caveats up front: a match is a reported CVE against a present package version, not proof it's reachable; and the database updates daily, so comparisons are only fair against the same DB. The side-by-side — hardened versus general-purpose — is the payoff, and scanning your own derived image reframes the job: the base is clean, so all that's left is keeping your direct dependencies patched. --fail-on high is the CI gate.</a:t>
             </a:r>
             <a:endParaRPr lang="en-US" dirty="0"/>
           </a:p>
@@ -1947,7 +1947,7 @@
           <a:p>
             <a:r>
               <a:rPr lang="en-US" dirty="0"/>
-              <a:t>Two tutorial sections cover why re-pulls are cheap. zstd:chunked is the modern OCI layer format that makes a layer seekable: the client can fetch just the chunks that changed instead of the whole layer. Combined with Hummingbird's frequent clean rebuilds, this keeps the bandwidth cost of staying current low — which matters when 'rebuild, don't patch' means images change often.</a:t>
+              <a:t>Two features cover why re-pulls are cheap. zstd:chunked is the modern OCI layer format that makes a layer seekable: the client can fetch just the chunks that changed instead of the whole layer. Combined with Hummingbird's frequent clean rebuilds, this keeps the bandwidth cost of staying current low — which matters when 'rebuild, don't patch' means images change often.</a:t>
             </a:r>
             <a:endParaRPr lang="en-US" dirty="0"/>
           </a:p>
@@ -2211,7 +2211,7 @@
           <a:p>
             <a:r>
               <a:rPr lang="en-US" dirty="0"/>
-              <a:t>The gotchas chapter is the most practical in the tutorial, and the closing demo trips each wire on purpose. The framing to land: none of these are defects — they're implicit assumptions from the wider ecosystem becoming visible against a minimal runtime. RUN needs a shell, so do shell work in the builder. Tools want HOME; set it. The bare 'python' alias is gone; use python3. Hummingbird's Postgres uses upstream env names. localhost resolves to IPv6 first, so test against 127.0.0.1. And when your COPYed-library list gets long, that's the signal to use UBI — Hummingbird isn't a moral position, it's a tool for the right workloads.</a:t>
+              <a:t>The gotchas topic is the most practical part, and the closing demo trips each wire on purpose. The framing to land: none of these are defects — they're implicit assumptions from the wider ecosystem becoming visible against a minimal runtime. RUN needs a shell, so do shell work in the builder. Tools want HOME; set it. The bare 'python' alias is gone; use python3. Hummingbird's Postgres uses upstream env names. localhost resolves to IPv6 first, so test against 127.0.0.1. And when your COPYed-library list gets long, that's the signal to use UBI — Hummingbird isn't a moral position, it's a tool for the right workloads.</a:t>
             </a:r>
             <a:endParaRPr lang="en-US" dirty="0"/>
           </a:p>
@@ -3003,7 +3003,7 @@
           <a:p>
             <a:r>
               <a:rPr lang="en-US" dirty="0"/>
-              <a:t>Same chain, reframed for our stack: Buildah/Konflux instead of Docker, the signed registry.access.redhat.com/hi path, OpenShift at deploy. Top row: the classic vectors. Bottom row: the Hummingbird answer. The story to tell — a hardened base turns the three hardest vectors (vulnerable base, vulnerable dependencies, build tampering) from 'trust us' into signed evidence you verify yourself, and the minimalism means there's simply less inside to be vulnerable. Be candid about the left edge: tampered source and a tampered Containerfile are the operator's job — branch protection, signed commits, pin the base by digest. Hummingbird gives you a trustworthy FROM; it can't stop an insecure Containerfile on top of it.</a:t>
+              <a:t>Same chain, reframed for our stack: Buildah/Konflux instead of Docker, the signed registry.access.redhat.com/hi path, OpenShift at deploy. Top row: the classic vectors. Bottom row: the Hummingbird answer. The story to tell — a hardened base turns the three hardest vectors (vulnerable base, vulnerable dependencies, build tampering) from 'trust us' into signed evidence you verify yourself, and the minimalism means there's simply less inside to be vulnerable. Be clear about the left edge: tampered source and a tampered Containerfile are the operator's job — branch protection, signed commits, pin the base by digest. Hummingbird gives you a trustworthy FROM; it can't stop an insecure Containerfile on top of it.</a:t>
             </a:r>
             <a:endParaRPr lang="en-US" dirty="0"/>
           </a:p>
@@ -3179,7 +3179,7 @@
           <a:p>
             <a:r>
               <a:rPr lang="en-US" dirty="0"/>
-              <a:t>The honest summary, and a good place to end an admin talk. Hummingbird owns the image — vulnerable base, vulnerable dependencies, build integrity, image authenticity — the part that's genuinely hard to do yourself and that you get for free. You own the edges — source and Containerfile integrity, platform hardening, and the admission gate that enforces verification for every deploy. The practical close: verify on pull with podman + cosign, and enforce it cluster-wide with an OpenShift admission policy so no one can route around the check — that's what closes the malicious-deployment-definition vector. A near-zero-CVE distroless base is the strongest single move on the supply chain precisely because it collapses the vectors that are hardest to defend one at a time.</a:t>
+              <a:t>The summary to land, and a good place to end an admin talk. Hummingbird owns the image — vulnerable base, vulnerable dependencies, build integrity, image authenticity — the part that's genuinely hard to do yourself and that you get for free. You own the edges — source and Containerfile integrity, platform hardening, and the admission gate that enforces verification for every deploy. The practical close: verify on pull with podman + cosign, and enforce it cluster-wide with an OpenShift admission policy so no one can route around the check — that's what closes the malicious-deployment-definition vector. A near-zero-CVE distroless base is the strongest single move on the supply chain precisely because it collapses the vectors that are hardest to defend one at a time.</a:t>
             </a:r>
             <a:endParaRPr lang="en-US" dirty="0"/>
           </a:p>
@@ -3267,7 +3267,7 @@
           <a:p>
             <a:r>
               <a:rPr lang="en-US" dirty="0"/>
-              <a:t>Recap the arc and point to where to go deeper. One idea drives everything — rebuild instead of patch — and it gives you distroless, near-zero-CVE images on a trust chain you may already rely on. The entire workflow fits on a laptop with Podman. The strongest closing note for an admin audience: near-zero CVE isn't something to take on faith — it's one Grype command away from being your own measurement, and the work that remains is the tractable part, keeping your own dependencies current. And it's not all-or-nothing: use Hummingbird where minimalism wins and UBI where breadth does. Everything in this deck — chapters, runnable examples, and the demos — lives in the tutorial repo and site.</a:t>
+              <a:t>Recap the arc and point to where to go deeper. One idea drives everything — rebuild instead of patch — and it gives you distroless, near-zero-CVE images on a trust chain you may already rely on. The entire workflow fits on a laptop with Podman. The strongest closing note for an admin audience: near-zero CVE isn't something to take on faith — it's one Grype command away from being your own measurement, and the work that remains is the tractable part, keeping your own dependencies current. And it's not all-or-nothing: use Hummingbird where minimalism wins and UBI where breadth does. Everything in this deck — the workflow, runnable examples, and the demos — lives in the project repo and site.</a:t>
             </a:r>
             <a:endParaRPr lang="en-US" dirty="0"/>
           </a:p>
@@ -3443,7 +3443,7 @@
           <a:p>
             <a:r>
               <a:rPr lang="en-US" dirty="0"/>
-              <a:t>Be candid here — it earns trust. 'Zero CVE' is the marketing; 'near-zero CVE' is the engineering truth, and the difference is just honesty about how vulnerability disclosure works. The zero line moves every day. What you can actually guarantee is: clean at publication, continuous rebuilds that chase the line, and functional testing so a security rebuild doesn't break your workload. In the CVE-scanning demo the audience watches Grype put real numbers behind this against a hardened image versus a general-purpose one.</a:t>
+              <a:t>Worth stating plainly — it earns trust. 'Zero CVE' is the marketing; 'near-zero CVE' is the engineering reality, and the difference is just how vulnerability disclosure works. The zero line moves every day. What you can actually guarantee is: clean at publication, continuous rebuilds that chase the line, and functional testing so a security rebuild doesn't break your workload. In the CVE-scanning demo the audience watches Grype put real numbers behind this against a hardened image versus a general-purpose one.</a:t>
             </a:r>
             <a:endParaRPr lang="en-US" dirty="0"/>
           </a:p>
@@ -3619,7 +3619,7 @@
           <a:p>
             <a:r>
               <a:rPr lang="en-US" dirty="0"/>
-              <a:t>Hummingbird does not replace UBI; most real platforms use both. The mental model: UBI when you need a familiar RHEL userspace and the ability to install packages — typically builder stages and middleware. Hummingbird when you want the smallest possible attack surface — typically the deploy stage that ships a compiled artifact. The Quarkus example in the tutorial literally does both: it builds on UBI (which ships Maven) and deploys on a hardened JRE. Mixing per-stage is the common, correct shape.</a:t>
+              <a:t>Hummingbird does not replace UBI; most real platforms use both. The mental model: UBI when you need a familiar RHEL userspace and the ability to install packages — typically builder stages and middleware. Hummingbird when you want the smallest possible attack surface — typically the deploy stage that ships a compiled artifact. The Quarkus example does both: it builds on UBI (which ships Maven) and deploys on a hardened JRE. Mixing per-stage is the common, correct shape.</a:t>
             </a:r>
             <a:endParaRPr lang="en-US" dirty="0"/>
           </a:p>
@@ -3795,7 +3795,7 @@
           <a:p>
             <a:r>
               <a:rPr lang="en-US" dirty="0"/>
-              <a:t>Every image ships in variants identified by tag suffix, plus per-architecture builds (AMD64 and Arm64) — which is how 45+ images become 150+ variants. Default aims to balance distroless principles with compatibility with existing upstream images; it's the production runtime. Builder retains the hardening but adds a package manager and shell so you can customize builds. FIPS adds validated cryptography for regulated environments. One honest nuance carried from the tutorial: 'no shell' is the safe assumption, not a universal guarantee — a few default images (Golang, Core Runtime, the full OpenJDK) include a shell because their ecosystems expect it. If your build pattern relies on shell-free runtime, pin the specific variant rather than assuming. Confirm exact tags against the catalog at images.redhat.com.</a:t>
+              <a:t>Every image ships in variants identified by tag suffix, plus per-architecture builds (AMD64 and Arm64) — which is how 45+ images become 150+ variants. Default aims to balance distroless principles with compatibility with existing upstream images; it's the production runtime. Builder retains the hardening but adds a package manager and shell so you can customize builds. FIPS adds validated cryptography for regulated environments. One nuance worth carrying over: 'no shell' is the safe assumption, not a universal guarantee — a few default images (Golang, Core Runtime, the full OpenJDK) include a shell because their ecosystems expect it. If your build pattern relies on shell-free runtime, pin the specific variant rather than assuming. Confirm exact tags against the catalog at images.redhat.com.</a:t>
             </a:r>
             <a:endParaRPr lang="en-US" dirty="0"/>
           </a:p>
@@ -4359,7 +4359,7 @@
                 <a:ea typeface="Red Hat Mono" pitchFamily="34" charset="-122"/>
                 <a:cs typeface="Red Hat Mono" pitchFamily="34" charset="-120"/>
               </a:rPr>
-              <a:t>r01.4</a:t>
+              <a:t>r01.5</a:t>
             </a:r>
             <a:endParaRPr lang="en-US" sz="1100" dirty="0"/>
           </a:p>
@@ -7128,7 +7128,7 @@
                 <a:ea typeface="Red Hat Text" pitchFamily="34" charset="-122"/>
                 <a:cs typeface="Red Hat Text" pitchFamily="34" charset="-120"/>
               </a:rPr>
-              <a:t>A diagram-led tour of the tutorial sections.</a:t>
+              <a:t>A diagram-led tour of the workflow.</a:t>
             </a:r>
             <a:endParaRPr lang="en-US" sz="1600" dirty="0"/>
           </a:p>
@@ -7279,7 +7279,7 @@
                 <a:ea typeface="Overpass" pitchFamily="34" charset="-122"/>
                 <a:cs typeface="Overpass" pitchFamily="34" charset="-120"/>
               </a:rPr>
-              <a:t>TUTORIAL · PREREQUISITES</a:t>
+              <a:t>WORKING WITH IMAGES · PREREQUISITES</a:t>
             </a:r>
             <a:endParaRPr lang="en-US" sz="1200" dirty="0"/>
           </a:p>
@@ -7507,7 +7507,7 @@
                 <a:ea typeface="Overpass" pitchFamily="34" charset="-122"/>
                 <a:cs typeface="Overpass" pitchFamily="34" charset="-120"/>
               </a:rPr>
-              <a:t>TUTORIAL · PODMAN BASICS</a:t>
+              <a:t>WORKING WITH IMAGES · PODMAN BASICS</a:t>
             </a:r>
             <a:endParaRPr lang="en-US" sz="1200" dirty="0"/>
           </a:p>
@@ -7735,7 +7735,7 @@
                 <a:ea typeface="Overpass" pitchFamily="34" charset="-122"/>
                 <a:cs typeface="Overpass" pitchFamily="34" charset="-120"/>
               </a:rPr>
-              <a:t>TUTORIAL · DEBUGGING</a:t>
+              <a:t>WORKING WITH IMAGES · DEBUGGING</a:t>
             </a:r>
             <a:endParaRPr lang="en-US" sz="1200" dirty="0"/>
           </a:p>
@@ -7963,7 +7963,7 @@
                 <a:ea typeface="Overpass" pitchFamily="34" charset="-122"/>
                 <a:cs typeface="Overpass" pitchFamily="34" charset="-120"/>
               </a:rPr>
-              <a:t>TUTORIAL · DEBUGGING</a:t>
+              <a:t>WORKING WITH IMAGES · DEBUGGING</a:t>
             </a:r>
             <a:endParaRPr lang="en-US" sz="1200" dirty="0"/>
           </a:p>
@@ -8388,7 +8388,7 @@
                 <a:ea typeface="Overpass" pitchFamily="34" charset="-122"/>
                 <a:cs typeface="Overpass" pitchFamily="34" charset="-120"/>
               </a:rPr>
-              <a:t>TUTORIAL · MULTI-STAGE BUILDS</a:t>
+              <a:t>WORKING WITH IMAGES · MULTI-STAGE BUILDS</a:t>
             </a:r>
             <a:endParaRPr lang="en-US" sz="1200" dirty="0"/>
           </a:p>
@@ -8616,7 +8616,7 @@
                 <a:ea typeface="Overpass" pitchFamily="34" charset="-122"/>
                 <a:cs typeface="Overpass" pitchFamily="34" charset="-120"/>
               </a:rPr>
-              <a:t>TUTORIAL · SBOM &amp; SIGNING</a:t>
+              <a:t>WORKING WITH IMAGES · SBOM &amp; SIGNING</a:t>
             </a:r>
             <a:endParaRPr lang="en-US" sz="1200" dirty="0"/>
           </a:p>
@@ -8844,7 +8844,7 @@
                 <a:ea typeface="Overpass" pitchFamily="34" charset="-122"/>
                 <a:cs typeface="Overpass" pitchFamily="34" charset="-120"/>
               </a:rPr>
-              <a:t>TUTORIAL · CVE SCANNING</a:t>
+              <a:t>WORKING WITH IMAGES · CVE SCANNING</a:t>
             </a:r>
             <a:endParaRPr lang="en-US" sz="1200" dirty="0"/>
           </a:p>
@@ -9127,7 +9127,7 @@
                 <a:ea typeface="Overpass" pitchFamily="34" charset="-122"/>
                 <a:cs typeface="Overpass" pitchFamily="34" charset="-120"/>
               </a:rPr>
-              <a:t>TUTORIAL · PODMAN COMPOSE</a:t>
+              <a:t>WORKING WITH IMAGES · PODMAN COMPOSE</a:t>
             </a:r>
             <a:endParaRPr lang="en-US" sz="1200" dirty="0"/>
           </a:p>
@@ -9355,7 +9355,7 @@
                 <a:ea typeface="Overpass" pitchFamily="34" charset="-122"/>
                 <a:cs typeface="Overpass" pitchFamily="34" charset="-120"/>
               </a:rPr>
-              <a:t>TUTORIAL · EFFICIENT LAYERS</a:t>
+              <a:t>WORKING WITH IMAGES · EFFICIENT LAYERS</a:t>
             </a:r>
             <a:endParaRPr lang="en-US" sz="1200" dirty="0"/>
           </a:p>
@@ -9583,7 +9583,7 @@
                 <a:ea typeface="Overpass" pitchFamily="34" charset="-122"/>
                 <a:cs typeface="Overpass" pitchFamily="34" charset="-120"/>
               </a:rPr>
-              <a:t>TUTORIAL · EFFICIENT LAYERS</a:t>
+              <a:t>WORKING WITH IMAGES · EFFICIENT LAYERS</a:t>
             </a:r>
             <a:endParaRPr lang="en-US" sz="1200" dirty="0"/>
           </a:p>
@@ -9811,7 +9811,7 @@
                 <a:ea typeface="Overpass" pitchFamily="34" charset="-122"/>
                 <a:cs typeface="Overpass" pitchFamily="34" charset="-120"/>
               </a:rPr>
-              <a:t>TUTORIAL · TRUSTED LIBRARIES</a:t>
+              <a:t>WORKING WITH IMAGES · TRUSTED LIBRARIES</a:t>
             </a:r>
             <a:endParaRPr lang="en-US" sz="1200" dirty="0"/>
           </a:p>
@@ -10094,7 +10094,7 @@
                 <a:ea typeface="Overpass" pitchFamily="34" charset="-122"/>
                 <a:cs typeface="Overpass" pitchFamily="34" charset="-120"/>
               </a:rPr>
-              <a:t>TUTORIAL · GOTCHAS</a:t>
+              <a:t>WORKING WITH IMAGES · GOTCHAS</a:t>
             </a:r>
             <a:endParaRPr lang="en-US" sz="1200" dirty="0"/>
           </a:p>
@@ -16226,7 +16226,7 @@
                 <a:ea typeface="Red Hat Text" pitchFamily="34" charset="-122"/>
                 <a:cs typeface="Red Hat Text" pitchFamily="34" charset="-120"/>
               </a:rPr>
-              <a:t>Tutorial &amp; demos: github.com/patterncatalyst/hummingbird-tutorial · patterncatalyst.github.io/hummingbird-tutorial</a:t>
+              <a:t>Docs &amp; demos: github.com/patterncatalyst/hummingbird-tutorial · patterncatalyst.github.io/hummingbird-tutorial</a:t>
             </a:r>
             <a:endParaRPr lang="en-US" sz="1500" dirty="0"/>
           </a:p>
@@ -16769,7 +16769,7 @@
                 <a:ea typeface="Red Hat Text" pitchFamily="34" charset="-122"/>
                 <a:cs typeface="Red Hat Text" pitchFamily="34" charset="-120"/>
               </a:rPr>
-              <a:t>Around 160 new CVEs are disclosed daily — an image that scans clean at 9 a.m. can have a CVE by 5 p.m. A literal, permanent zero is not achievable, and the honest phrase is “near-zero”.</a:t>
+              <a:t>Around 160 new CVEs are disclosed daily — an image that scans clean at 9 a.m. can have a CVE by 5 p.m. A literal, permanent zero is not achievable, and the accurate phrase is “near-zero”.</a:t>
             </a:r>
             <a:endParaRPr lang="en-US" sz="1600" dirty="0"/>
           </a:p>

</xml_diff>